<commit_message>
sync presentation deck, pptx, pointers, and recording script with honest builder narrative
</commit_message>
<xml_diff>
--- a/docs/presentation/ecoloop-presentation.pptx
+++ b/docs/presentation/ecoloop-presentation.pptx
@@ -3203,6 +3203,1357 @@
         </p:nvSpPr>
         <p:spPr>
           <a:xfrm>
+            <a:off x="822960" y="640080"/>
+            <a:ext cx="10515600" cy="1188720"/>
+          </a:xfrm>
+          <a:prstGeom prst="rect">
+            <a:avLst/>
+          </a:prstGeom>
+          <a:noFill/>
+        </p:spPr>
+        <p:txBody>
+          <a:bodyPr wrap="square" lIns="0" tIns="0" rIns="0" bIns="0">
+            <a:spAutoFit/>
+          </a:bodyPr>
+          <a:lstStyle/>
+          <a:p>
+            <a:pPr>
+              <a:defRPr sz="3600" b="1">
+                <a:solidFill>
+                  <a:srgbClr val="171A18"/>
+                </a:solidFill>
+                <a:latin typeface="Plus Jakarta Sans"/>
+              </a:defRPr>
+            </a:pPr>
+            <a:r>
+              <a:t>Chatbot vs Agent Workspace</a:t>
+            </a:r>
+          </a:p>
+          <a:p>
+            <a:pPr>
+              <a:spcBef>
+                <a:spcPts val="600"/>
+              </a:spcBef>
+              <a:defRPr sz="1700">
+                <a:solidFill>
+                  <a:srgbClr val="526058"/>
+                </a:solidFill>
+                <a:latin typeface="Plus Jakarta Sans"/>
+              </a:defRPr>
+            </a:pPr>
+            <a:r>
+              <a:t>The difference between copy-pasting snippets and letting an agent build inside your files.</a:t>
+            </a:r>
+          </a:p>
+        </p:txBody>
+      </p:sp>
+      <p:sp>
+        <p:nvSpPr>
+          <p:cNvPr id="3" name="Rectangle 2"/>
+          <p:cNvSpPr/>
+          <p:nvPr/>
+        </p:nvSpPr>
+        <p:spPr>
+          <a:xfrm>
+            <a:off x="822960" y="2103120"/>
+            <a:ext cx="5029200" cy="3840480"/>
+          </a:xfrm>
+          <a:prstGeom prst="rect">
+            <a:avLst/>
+          </a:prstGeom>
+          <a:solidFill>
+            <a:srgbClr val="F8FAF8"/>
+          </a:solidFill>
+          <a:ln w="19050">
+            <a:solidFill>
+              <a:srgbClr val="E2E8E0"/>
+            </a:solidFill>
+          </a:ln>
+        </p:spPr>
+        <p:style>
+          <a:lnRef idx="1">
+            <a:schemeClr val="accent1"/>
+          </a:lnRef>
+          <a:fillRef idx="3">
+            <a:schemeClr val="accent1"/>
+          </a:fillRef>
+          <a:effectRef idx="2">
+            <a:schemeClr val="accent1"/>
+          </a:effectRef>
+          <a:fontRef idx="minor">
+            <a:schemeClr val="lt1"/>
+          </a:fontRef>
+        </p:style>
+        <p:txBody>
+          <a:bodyPr rtlCol="0" anchor="ctr" wrap="square"/>
+          <a:lstStyle/>
+          <a:p>
+            <a:pPr algn="ctr">
+              <a:defRPr sz="1800" b="1">
+                <a:solidFill>
+                  <a:srgbClr val="526058"/>
+                </a:solidFill>
+                <a:latin typeface="Plus Jakarta Sans"/>
+              </a:defRPr>
+            </a:pPr>
+            <a:r>
+              <a:t>ChatGPT Web Window</a:t>
+            </a:r>
+          </a:p>
+          <a:p>
+            <a:pPr algn="ctr">
+              <a:spcBef>
+                <a:spcPts val="1400"/>
+              </a:spcBef>
+              <a:defRPr sz="1300">
+                <a:solidFill>
+                  <a:srgbClr val="526058"/>
+                </a:solidFill>
+                <a:latin typeface="Plus Jakarta Sans"/>
+              </a:defRPr>
+            </a:pPr>
+            <a:r>
+              <a:t>[DROP CHATGPT SCREENSHOT HERE]</a:t>
+            </a:r>
+            <a:br/>
+            <a:br/>
+            <a:r>
+              <a:t>• Copy-pasting snippets back and forth</a:t>
+            </a:r>
+            <a:br/>
+            <a:r>
+              <a:t>• Forgets project context easily</a:t>
+            </a:r>
+            <a:br/>
+            <a:r>
+              <a:t>• Cannot see or edit your local project files</a:t>
+            </a:r>
+          </a:p>
+        </p:txBody>
+      </p:sp>
+      <p:sp>
+        <p:nvSpPr>
+          <p:cNvPr id="4" name="Rectangle 3"/>
+          <p:cNvSpPr/>
+          <p:nvPr/>
+        </p:nvSpPr>
+        <p:spPr>
+          <a:xfrm>
+            <a:off x="6309360" y="2103120"/>
+            <a:ext cx="5029200" cy="3840480"/>
+          </a:xfrm>
+          <a:prstGeom prst="rect">
+            <a:avLst/>
+          </a:prstGeom>
+          <a:solidFill>
+            <a:srgbClr val="F0F6F2"/>
+          </a:solidFill>
+          <a:ln w="19050">
+            <a:solidFill>
+              <a:srgbClr val="1F6B4F"/>
+            </a:solidFill>
+          </a:ln>
+        </p:spPr>
+        <p:style>
+          <a:lnRef idx="1">
+            <a:schemeClr val="accent1"/>
+          </a:lnRef>
+          <a:fillRef idx="3">
+            <a:schemeClr val="accent1"/>
+          </a:fillRef>
+          <a:effectRef idx="2">
+            <a:schemeClr val="accent1"/>
+          </a:effectRef>
+          <a:fontRef idx="minor">
+            <a:schemeClr val="lt1"/>
+          </a:fontRef>
+        </p:style>
+        <p:txBody>
+          <a:bodyPr rtlCol="0" anchor="ctr" wrap="square"/>
+          <a:lstStyle/>
+          <a:p>
+            <a:pPr algn="ctr">
+              <a:defRPr sz="1800" b="1">
+                <a:solidFill>
+                  <a:srgbClr val="1F6B4F"/>
+                </a:solidFill>
+                <a:latin typeface="Plus Jakarta Sans"/>
+              </a:defRPr>
+            </a:pPr>
+            <a:r>
+              <a:t>Agent Workspace (Antigravity / OpenCode)</a:t>
+            </a:r>
+          </a:p>
+          <a:p>
+            <a:pPr algn="ctr">
+              <a:spcBef>
+                <a:spcPts val="1400"/>
+              </a:spcBef>
+              <a:defRPr sz="1300">
+                <a:solidFill>
+                  <a:srgbClr val="171A18"/>
+                </a:solidFill>
+                <a:latin typeface="Plus Jakarta Sans"/>
+              </a:defRPr>
+            </a:pPr>
+            <a:r>
+              <a:t>[DROP ANTIGRAVITY SCREENSHOT HERE]</a:t>
+            </a:r>
+            <a:br/>
+            <a:br/>
+            <a:r>
+              <a:t>• Reads and edits real repository files</a:t>
+            </a:r>
+            <a:br/>
+            <a:r>
+              <a:t>• Understands full folder structure and context</a:t>
+            </a:r>
+            <a:br/>
+            <a:r>
+              <a:t>• Runs terminal builds and tests autonomously</a:t>
+            </a:r>
+          </a:p>
+        </p:txBody>
+      </p:sp>
+    </p:spTree>
+  </p:cSld>
+  <p:clrMapOvr>
+    <a:masterClrMapping/>
+  </p:clrMapOvr>
+</p:sld>
+</file>
+
+<file path=ppt/slides/slide11.xml><?xml version="1.0" encoding="utf-8"?>
+<p:sld xmlns:a="http://schemas.openxmlformats.org/drawingml/2006/main" xmlns:p="http://schemas.openxmlformats.org/presentationml/2006/main" xmlns:r="http://schemas.openxmlformats.org/officeDocument/2006/relationships">
+  <p:cSld>
+    <p:spTree>
+      <p:nvGrpSpPr>
+        <p:cNvPr id="1" name=""/>
+        <p:cNvGrpSpPr/>
+        <p:nvPr/>
+      </p:nvGrpSpPr>
+      <p:grpSpPr/>
+      <p:sp>
+        <p:nvSpPr>
+          <p:cNvPr id="2" name="TextBox 1"/>
+          <p:cNvSpPr txBox="1"/>
+          <p:nvPr/>
+        </p:nvSpPr>
+        <p:spPr>
+          <a:xfrm>
+            <a:off x="822960" y="640080"/>
+            <a:ext cx="10515600" cy="1188720"/>
+          </a:xfrm>
+          <a:prstGeom prst="rect">
+            <a:avLst/>
+          </a:prstGeom>
+          <a:noFill/>
+        </p:spPr>
+        <p:txBody>
+          <a:bodyPr wrap="square" lIns="0" tIns="0" rIns="0" bIns="0">
+            <a:spAutoFit/>
+          </a:bodyPr>
+          <a:lstStyle/>
+          <a:p>
+            <a:pPr>
+              <a:defRPr sz="3600" b="1">
+                <a:solidFill>
+                  <a:srgbClr val="171A18"/>
+                </a:solidFill>
+                <a:latin typeface="Plus Jakarta Sans"/>
+              </a:defRPr>
+            </a:pPr>
+            <a:r>
+              <a:t>How Working with an Agent Actually Looks</a:t>
+            </a:r>
+          </a:p>
+          <a:p>
+            <a:pPr>
+              <a:spcBef>
+                <a:spcPts val="600"/>
+              </a:spcBef>
+              <a:defRPr sz="1700">
+                <a:solidFill>
+                  <a:srgbClr val="526058"/>
+                </a:solidFill>
+                <a:latin typeface="Plus Jakarta Sans"/>
+              </a:defRPr>
+            </a:pPr>
+            <a:r>
+              <a:t>A practical 4-step loop of specifying, editing, testing, and self-repairing.</a:t>
+            </a:r>
+          </a:p>
+        </p:txBody>
+      </p:sp>
+      <p:sp>
+        <p:nvSpPr>
+          <p:cNvPr id="3" name="Rectangle 2"/>
+          <p:cNvSpPr/>
+          <p:nvPr/>
+        </p:nvSpPr>
+        <p:spPr>
+          <a:xfrm>
+            <a:off x="822960" y="2286000"/>
+            <a:ext cx="2514600" cy="3474720"/>
+          </a:xfrm>
+          <a:prstGeom prst="rect">
+            <a:avLst/>
+          </a:prstGeom>
+          <a:solidFill>
+            <a:srgbClr val="F8FAF8"/>
+          </a:solidFill>
+          <a:ln w="12700">
+            <a:solidFill>
+              <a:srgbClr val="E2E8E0"/>
+            </a:solidFill>
+          </a:ln>
+        </p:spPr>
+        <p:style>
+          <a:lnRef idx="1">
+            <a:schemeClr val="accent1"/>
+          </a:lnRef>
+          <a:fillRef idx="3">
+            <a:schemeClr val="accent1"/>
+          </a:fillRef>
+          <a:effectRef idx="2">
+            <a:schemeClr val="accent1"/>
+          </a:effectRef>
+          <a:fontRef idx="minor">
+            <a:schemeClr val="lt1"/>
+          </a:fontRef>
+        </p:style>
+        <p:txBody>
+          <a:bodyPr rtlCol="0" anchor="ctr" wrap="square"/>
+          <a:lstStyle/>
+          <a:p>
+            <a:pPr algn="ctr">
+              <a:defRPr sz="1100" b="1">
+                <a:solidFill>
+                  <a:srgbClr val="1F6B4F"/>
+                </a:solidFill>
+                <a:latin typeface="JetBrains Mono"/>
+              </a:defRPr>
+            </a:pPr>
+            <a:r>
+              <a:t>STAGE 01</a:t>
+            </a:r>
+          </a:p>
+          <a:p>
+            <a:pPr>
+              <a:spcBef>
+                <a:spcPts val="600"/>
+              </a:spcBef>
+              <a:defRPr sz="1700" b="1">
+                <a:solidFill>
+                  <a:srgbClr val="171A18"/>
+                </a:solidFill>
+                <a:latin typeface="Plus Jakarta Sans"/>
+              </a:defRPr>
+            </a:pPr>
+            <a:r>
+              <a:t>Write the Spec</a:t>
+            </a:r>
+          </a:p>
+          <a:p>
+            <a:pPr>
+              <a:spcBef>
+                <a:spcPts val="1200"/>
+              </a:spcBef>
+              <a:defRPr sz="1300">
+                <a:solidFill>
+                  <a:srgbClr val="526058"/>
+                </a:solidFill>
+                <a:latin typeface="Plus Jakarta Sans"/>
+              </a:defRPr>
+            </a:pPr>
+            <a:r>
+              <a:t>Describe what you want in plain language: colors, component layout, and behavior rules.</a:t>
+            </a:r>
+          </a:p>
+        </p:txBody>
+      </p:sp>
+      <p:sp>
+        <p:nvSpPr>
+          <p:cNvPr id="4" name="Rectangle 3"/>
+          <p:cNvSpPr/>
+          <p:nvPr/>
+        </p:nvSpPr>
+        <p:spPr>
+          <a:xfrm>
+            <a:off x="3520440" y="2286000"/>
+            <a:ext cx="2514600" cy="3474720"/>
+          </a:xfrm>
+          <a:prstGeom prst="rect">
+            <a:avLst/>
+          </a:prstGeom>
+          <a:solidFill>
+            <a:srgbClr val="F8FAF8"/>
+          </a:solidFill>
+          <a:ln w="12700">
+            <a:solidFill>
+              <a:srgbClr val="E2E8E0"/>
+            </a:solidFill>
+          </a:ln>
+        </p:spPr>
+        <p:style>
+          <a:lnRef idx="1">
+            <a:schemeClr val="accent1"/>
+          </a:lnRef>
+          <a:fillRef idx="3">
+            <a:schemeClr val="accent1"/>
+          </a:fillRef>
+          <a:effectRef idx="2">
+            <a:schemeClr val="accent1"/>
+          </a:effectRef>
+          <a:fontRef idx="minor">
+            <a:schemeClr val="lt1"/>
+          </a:fontRef>
+        </p:style>
+        <p:txBody>
+          <a:bodyPr rtlCol="0" anchor="ctr" wrap="square"/>
+          <a:lstStyle/>
+          <a:p>
+            <a:pPr algn="ctr">
+              <a:defRPr sz="1100" b="1">
+                <a:solidFill>
+                  <a:srgbClr val="1F6B4F"/>
+                </a:solidFill>
+                <a:latin typeface="JetBrains Mono"/>
+              </a:defRPr>
+            </a:pPr>
+            <a:r>
+              <a:t>STAGE 02</a:t>
+            </a:r>
+          </a:p>
+          <a:p>
+            <a:pPr>
+              <a:spcBef>
+                <a:spcPts val="600"/>
+              </a:spcBef>
+              <a:defRPr sz="1700" b="1">
+                <a:solidFill>
+                  <a:srgbClr val="171A18"/>
+                </a:solidFill>
+                <a:latin typeface="Plus Jakarta Sans"/>
+              </a:defRPr>
+            </a:pPr>
+            <a:r>
+              <a:t>Agent Edits Files</a:t>
+            </a:r>
+          </a:p>
+          <a:p>
+            <a:pPr>
+              <a:spcBef>
+                <a:spcPts val="1200"/>
+              </a:spcBef>
+              <a:defRPr sz="1300">
+                <a:solidFill>
+                  <a:srgbClr val="526058"/>
+                </a:solidFill>
+                <a:latin typeface="Plus Jakarta Sans"/>
+              </a:defRPr>
+            </a:pPr>
+            <a:r>
+              <a:t>The agent inspects your repository, writes components, and updates project files directly.</a:t>
+            </a:r>
+          </a:p>
+        </p:txBody>
+      </p:sp>
+      <p:sp>
+        <p:nvSpPr>
+          <p:cNvPr id="5" name="Rectangle 4"/>
+          <p:cNvSpPr/>
+          <p:nvPr/>
+        </p:nvSpPr>
+        <p:spPr>
+          <a:xfrm>
+            <a:off x="6217920" y="2286000"/>
+            <a:ext cx="2514600" cy="3474720"/>
+          </a:xfrm>
+          <a:prstGeom prst="rect">
+            <a:avLst/>
+          </a:prstGeom>
+          <a:solidFill>
+            <a:srgbClr val="F8FAF8"/>
+          </a:solidFill>
+          <a:ln w="12700">
+            <a:solidFill>
+              <a:srgbClr val="E2E8E0"/>
+            </a:solidFill>
+          </a:ln>
+        </p:spPr>
+        <p:style>
+          <a:lnRef idx="1">
+            <a:schemeClr val="accent1"/>
+          </a:lnRef>
+          <a:fillRef idx="3">
+            <a:schemeClr val="accent1"/>
+          </a:fillRef>
+          <a:effectRef idx="2">
+            <a:schemeClr val="accent1"/>
+          </a:effectRef>
+          <a:fontRef idx="minor">
+            <a:schemeClr val="lt1"/>
+          </a:fontRef>
+        </p:style>
+        <p:txBody>
+          <a:bodyPr rtlCol="0" anchor="ctr" wrap="square"/>
+          <a:lstStyle/>
+          <a:p>
+            <a:pPr algn="ctr">
+              <a:defRPr sz="1100" b="1">
+                <a:solidFill>
+                  <a:srgbClr val="1F6B4F"/>
+                </a:solidFill>
+                <a:latin typeface="JetBrains Mono"/>
+              </a:defRPr>
+            </a:pPr>
+            <a:r>
+              <a:t>STAGE 03</a:t>
+            </a:r>
+          </a:p>
+          <a:p>
+            <a:pPr>
+              <a:spcBef>
+                <a:spcPts val="600"/>
+              </a:spcBef>
+              <a:defRPr sz="1700" b="1">
+                <a:solidFill>
+                  <a:srgbClr val="171A18"/>
+                </a:solidFill>
+                <a:latin typeface="Plus Jakarta Sans"/>
+              </a:defRPr>
+            </a:pPr>
+            <a:r>
+              <a:t>You Test Locally</a:t>
+            </a:r>
+          </a:p>
+          <a:p>
+            <a:pPr>
+              <a:spcBef>
+                <a:spcPts val="1200"/>
+              </a:spcBef>
+              <a:defRPr sz="1300">
+                <a:solidFill>
+                  <a:srgbClr val="526058"/>
+                </a:solidFill>
+                <a:latin typeface="Plus Jakarta Sans"/>
+              </a:defRPr>
+            </a:pPr>
+            <a:r>
+              <a:t>You run the app in your browser, click the buttons, and see what works or what broke.</a:t>
+            </a:r>
+          </a:p>
+        </p:txBody>
+      </p:sp>
+      <p:sp>
+        <p:nvSpPr>
+          <p:cNvPr id="6" name="Rectangle 5"/>
+          <p:cNvSpPr/>
+          <p:nvPr/>
+        </p:nvSpPr>
+        <p:spPr>
+          <a:xfrm>
+            <a:off x="8915400" y="2286000"/>
+            <a:ext cx="2514600" cy="3474720"/>
+          </a:xfrm>
+          <a:prstGeom prst="rect">
+            <a:avLst/>
+          </a:prstGeom>
+          <a:solidFill>
+            <a:srgbClr val="F8FAF8"/>
+          </a:solidFill>
+          <a:ln w="12700">
+            <a:solidFill>
+              <a:srgbClr val="E2E8E0"/>
+            </a:solidFill>
+          </a:ln>
+        </p:spPr>
+        <p:style>
+          <a:lnRef idx="1">
+            <a:schemeClr val="accent1"/>
+          </a:lnRef>
+          <a:fillRef idx="3">
+            <a:schemeClr val="accent1"/>
+          </a:fillRef>
+          <a:effectRef idx="2">
+            <a:schemeClr val="accent1"/>
+          </a:effectRef>
+          <a:fontRef idx="minor">
+            <a:schemeClr val="lt1"/>
+          </a:fontRef>
+        </p:style>
+        <p:txBody>
+          <a:bodyPr rtlCol="0" anchor="ctr" wrap="square"/>
+          <a:lstStyle/>
+          <a:p>
+            <a:pPr algn="ctr">
+              <a:defRPr sz="1100" b="1">
+                <a:solidFill>
+                  <a:srgbClr val="1F6B4F"/>
+                </a:solidFill>
+                <a:latin typeface="JetBrains Mono"/>
+              </a:defRPr>
+            </a:pPr>
+            <a:r>
+              <a:t>STAGE 04</a:t>
+            </a:r>
+          </a:p>
+          <a:p>
+            <a:pPr>
+              <a:spcBef>
+                <a:spcPts val="600"/>
+              </a:spcBef>
+              <a:defRPr sz="1700" b="1">
+                <a:solidFill>
+                  <a:srgbClr val="171A18"/>
+                </a:solidFill>
+                <a:latin typeface="Plus Jakarta Sans"/>
+              </a:defRPr>
+            </a:pPr>
+            <a:r>
+              <a:t>Agent Fixes Bugs</a:t>
+            </a:r>
+          </a:p>
+          <a:p>
+            <a:pPr>
+              <a:spcBef>
+                <a:spcPts val="1200"/>
+              </a:spcBef>
+              <a:defRPr sz="1300">
+                <a:solidFill>
+                  <a:srgbClr val="526058"/>
+                </a:solidFill>
+                <a:latin typeface="Plus Jakarta Sans"/>
+              </a:defRPr>
+            </a:pPr>
+            <a:r>
+              <a:t>You paste the error or unexpected behavior back to the agent; it reads the log and repairs it.</a:t>
+            </a:r>
+          </a:p>
+        </p:txBody>
+      </p:sp>
+    </p:spTree>
+  </p:cSld>
+  <p:clrMapOvr>
+    <a:masterClrMapping/>
+  </p:clrMapOvr>
+</p:sld>
+</file>
+
+<file path=ppt/slides/slide12.xml><?xml version="1.0" encoding="utf-8"?>
+<p:sld xmlns:a="http://schemas.openxmlformats.org/drawingml/2006/main" xmlns:p="http://schemas.openxmlformats.org/presentationml/2006/main" xmlns:r="http://schemas.openxmlformats.org/officeDocument/2006/relationships">
+  <p:cSld>
+    <p:spTree>
+      <p:nvGrpSpPr>
+        <p:cNvPr id="1" name=""/>
+        <p:cNvGrpSpPr/>
+        <p:nvPr/>
+      </p:nvGrpSpPr>
+      <p:grpSpPr/>
+      <p:sp>
+        <p:nvSpPr>
+          <p:cNvPr id="2" name="TextBox 1"/>
+          <p:cNvSpPr txBox="1"/>
+          <p:nvPr/>
+        </p:nvSpPr>
+        <p:spPr>
+          <a:xfrm>
+            <a:off x="822960" y="640080"/>
+            <a:ext cx="10515600" cy="1188720"/>
+          </a:xfrm>
+          <a:prstGeom prst="rect">
+            <a:avLst/>
+          </a:prstGeom>
+          <a:noFill/>
+        </p:spPr>
+        <p:txBody>
+          <a:bodyPr wrap="square" lIns="0" tIns="0" rIns="0" bIns="0">
+            <a:spAutoFit/>
+          </a:bodyPr>
+          <a:lstStyle/>
+          <a:p>
+            <a:pPr>
+              <a:defRPr sz="3600" b="1">
+                <a:solidFill>
+                  <a:srgbClr val="171A18"/>
+                </a:solidFill>
+                <a:latin typeface="Plus Jakarta Sans"/>
+              </a:defRPr>
+            </a:pPr>
+            <a:r>
+              <a:t>Replicating This Workflow: OpenCode</a:t>
+            </a:r>
+          </a:p>
+          <a:p>
+            <a:pPr>
+              <a:spcBef>
+                <a:spcPts val="600"/>
+              </a:spcBef>
+              <a:defRPr sz="1700">
+                <a:solidFill>
+                  <a:srgbClr val="526058"/>
+                </a:solidFill>
+                <a:latin typeface="Plus Jakarta Sans"/>
+              </a:defRPr>
+            </a:pPr>
+            <a:r>
+              <a:t>An open-source terminal agent that gives you the same autonomous capabilities.</a:t>
+            </a:r>
+          </a:p>
+        </p:txBody>
+      </p:sp>
+      <p:sp>
+        <p:nvSpPr>
+          <p:cNvPr id="3" name="TextBox 2"/>
+          <p:cNvSpPr txBox="1"/>
+          <p:nvPr/>
+        </p:nvSpPr>
+        <p:spPr>
+          <a:xfrm>
+            <a:off x="822960" y="2103120"/>
+            <a:ext cx="5120640" cy="4114800"/>
+          </a:xfrm>
+          <a:prstGeom prst="rect">
+            <a:avLst/>
+          </a:prstGeom>
+          <a:noFill/>
+        </p:spPr>
+        <p:txBody>
+          <a:bodyPr wrap="square">
+            <a:spAutoFit/>
+          </a:bodyPr>
+          <a:lstStyle/>
+          <a:p>
+            <a:pPr>
+              <a:defRPr sz="2000" b="1">
+                <a:solidFill>
+                  <a:srgbClr val="1F6B4F"/>
+                </a:solidFill>
+                <a:latin typeface="Plus Jakarta Sans"/>
+              </a:defRPr>
+            </a:pPr>
+            <a:r>
+              <a:t>Why OpenCode for Students?</a:t>
+            </a:r>
+          </a:p>
+          <a:p>
+            <a:pPr>
+              <a:spcBef>
+                <a:spcPts val="1400"/>
+              </a:spcBef>
+            </a:pPr>
+            <a:r>
+              <a:rPr sz="1000">
+                <a:solidFill>
+                  <a:srgbClr val="1F6B4F"/>
+                </a:solidFill>
+                <a:latin typeface="Plus Jakarta Sans"/>
+              </a:rPr>
+              <a:t>■  </a:t>
+            </a:r>
+            <a:r>
+              <a:rPr sz="1500" b="1">
+                <a:solidFill>
+                  <a:srgbClr val="171A18"/>
+                </a:solidFill>
+                <a:latin typeface="Plus Jakarta Sans"/>
+              </a:rPr>
+              <a:t>100% Free &amp; Open Source:
+</a:t>
+            </a:r>
+            <a:r>
+              <a:rPr sz="1400">
+                <a:solidFill>
+                  <a:srgbClr val="526058"/>
+                </a:solidFill>
+                <a:latin typeface="Plus Jakarta Sans"/>
+              </a:rPr>
+              <a:t>   Created by Anomaly (GitHub: anomalyco/opencode). Zero subscriptions or vendor lock-in.</a:t>
+            </a:r>
+          </a:p>
+          <a:p>
+            <a:pPr>
+              <a:spcBef>
+                <a:spcPts val="1400"/>
+              </a:spcBef>
+            </a:pPr>
+            <a:r>
+              <a:rPr sz="1000">
+                <a:solidFill>
+                  <a:srgbClr val="1F6B4F"/>
+                </a:solidFill>
+                <a:latin typeface="Plus Jakarta Sans"/>
+              </a:rPr>
+              <a:t>■  </a:t>
+            </a:r>
+            <a:r>
+              <a:rPr sz="1500" b="1">
+                <a:solidFill>
+                  <a:srgbClr val="171A18"/>
+                </a:solidFill>
+                <a:latin typeface="Plus Jakarta Sans"/>
+              </a:rPr>
+              <a:t>Lives in Your Terminal:
+</a:t>
+            </a:r>
+            <a:r>
+              <a:rPr sz="1400">
+                <a:solidFill>
+                  <a:srgbClr val="526058"/>
+                </a:solidFill>
+                <a:latin typeface="Plus Jakarta Sans"/>
+              </a:rPr>
+              <a:t>   Reads your project files, edits code, and runs local commands just like specialized agent harnesses.</a:t>
+            </a:r>
+          </a:p>
+          <a:p>
+            <a:pPr>
+              <a:spcBef>
+                <a:spcPts val="1400"/>
+              </a:spcBef>
+            </a:pPr>
+            <a:r>
+              <a:rPr sz="1000">
+                <a:solidFill>
+                  <a:srgbClr val="1F6B4F"/>
+                </a:solidFill>
+                <a:latin typeface="Plus Jakarta Sans"/>
+              </a:rPr>
+              <a:t>■  </a:t>
+            </a:r>
+            <a:r>
+              <a:rPr sz="1500" b="1">
+                <a:solidFill>
+                  <a:srgbClr val="171A18"/>
+                </a:solidFill>
+                <a:latin typeface="Plus Jakarta Sans"/>
+              </a:rPr>
+              <a:t>Dual Execution Modes:
+</a:t>
+            </a:r>
+            <a:r>
+              <a:rPr sz="1400">
+                <a:solidFill>
+                  <a:srgbClr val="526058"/>
+                </a:solidFill>
+                <a:latin typeface="Plus Jakarta Sans"/>
+              </a:rPr>
+              <a:t>   Plan Mode reviews architecture safely; Build Mode executes real code changes.</a:t>
+            </a:r>
+          </a:p>
+        </p:txBody>
+      </p:sp>
+      <p:sp>
+        <p:nvSpPr>
+          <p:cNvPr id="4" name="Rectangle 3"/>
+          <p:cNvSpPr/>
+          <p:nvPr/>
+        </p:nvSpPr>
+        <p:spPr>
+          <a:xfrm>
+            <a:off x="6309360" y="2103120"/>
+            <a:ext cx="5029200" cy="3291840"/>
+          </a:xfrm>
+          <a:prstGeom prst="rect">
+            <a:avLst/>
+          </a:prstGeom>
+          <a:solidFill>
+            <a:srgbClr val="F8FAF8"/>
+          </a:solidFill>
+          <a:ln w="19050">
+            <a:solidFill>
+              <a:srgbClr val="1F6B4F"/>
+            </a:solidFill>
+          </a:ln>
+        </p:spPr>
+        <p:style>
+          <a:lnRef idx="1">
+            <a:schemeClr val="accent1"/>
+          </a:lnRef>
+          <a:fillRef idx="3">
+            <a:schemeClr val="accent1"/>
+          </a:fillRef>
+          <a:effectRef idx="2">
+            <a:schemeClr val="accent1"/>
+          </a:effectRef>
+          <a:fontRef idx="minor">
+            <a:schemeClr val="lt1"/>
+          </a:fontRef>
+        </p:style>
+        <p:txBody>
+          <a:bodyPr rtlCol="0" anchor="ctr" wrap="square"/>
+          <a:lstStyle/>
+          <a:p>
+            <a:pPr algn="ctr">
+              <a:defRPr sz="1300">
+                <a:solidFill>
+                  <a:srgbClr val="526058"/>
+                </a:solidFill>
+                <a:latin typeface="JetBrains Mono"/>
+              </a:defRPr>
+            </a:pPr>
+            <a:r>
+              <a:t>// Quick Installation in 60 Seconds</a:t>
+            </a:r>
+          </a:p>
+          <a:p>
+            <a:pPr>
+              <a:spcBef>
+                <a:spcPts val="800"/>
+              </a:spcBef>
+              <a:defRPr sz="1400" b="1">
+                <a:solidFill>
+                  <a:srgbClr val="1F6B4F"/>
+                </a:solidFill>
+                <a:latin typeface="JetBrains Mono"/>
+              </a:defRPr>
+            </a:pPr>
+            <a:r>
+              <a:t>$ npm install -g @opencode/cli</a:t>
+            </a:r>
+          </a:p>
+          <a:p>
+            <a:pPr>
+              <a:spcBef>
+                <a:spcPts val="800"/>
+              </a:spcBef>
+              <a:defRPr sz="1400" b="1">
+                <a:solidFill>
+                  <a:srgbClr val="1F6B4F"/>
+                </a:solidFill>
+                <a:latin typeface="JetBrains Mono"/>
+              </a:defRPr>
+            </a:pPr>
+            <a:r>
+              <a:t>$ cd ./my-project</a:t>
+            </a:r>
+          </a:p>
+          <a:p>
+            <a:pPr>
+              <a:spcBef>
+                <a:spcPts val="800"/>
+              </a:spcBef>
+              <a:defRPr sz="1400" b="1">
+                <a:solidFill>
+                  <a:srgbClr val="1F6B4F"/>
+                </a:solidFill>
+                <a:latin typeface="JetBrains Mono"/>
+              </a:defRPr>
+            </a:pPr>
+            <a:r>
+              <a:t>$ opencode</a:t>
+            </a:r>
+          </a:p>
+          <a:p>
+            <a:pPr>
+              <a:spcBef>
+                <a:spcPts val="800"/>
+              </a:spcBef>
+              <a:defRPr sz="1400" b="1">
+                <a:solidFill>
+                  <a:srgbClr val="526058"/>
+                </a:solidFill>
+                <a:latin typeface="JetBrains Mono"/>
+              </a:defRPr>
+            </a:pPr>
+          </a:p>
+          <a:p>
+            <a:pPr>
+              <a:spcBef>
+                <a:spcPts val="800"/>
+              </a:spcBef>
+              <a:defRPr sz="1400" b="1">
+                <a:solidFill>
+                  <a:srgbClr val="526058"/>
+                </a:solidFill>
+                <a:latin typeface="JetBrains Mono"/>
+              </a:defRPr>
+            </a:pPr>
+            <a:r>
+              <a:t>// Runs on macOS, Linux, and Windows WSL</a:t>
+            </a:r>
+          </a:p>
+        </p:txBody>
+      </p:sp>
+    </p:spTree>
+  </p:cSld>
+  <p:clrMapOvr>
+    <a:masterClrMapping/>
+  </p:clrMapOvr>
+</p:sld>
+</file>
+
+<file path=ppt/slides/slide13.xml><?xml version="1.0" encoding="utf-8"?>
+<p:sld xmlns:a="http://schemas.openxmlformats.org/drawingml/2006/main" xmlns:p="http://schemas.openxmlformats.org/presentationml/2006/main" xmlns:r="http://schemas.openxmlformats.org/officeDocument/2006/relationships">
+  <p:cSld>
+    <p:spTree>
+      <p:nvGrpSpPr>
+        <p:cNvPr id="1" name=""/>
+        <p:cNvGrpSpPr/>
+        <p:nvPr/>
+      </p:nvGrpSpPr>
+      <p:grpSpPr/>
+      <p:sp>
+        <p:nvSpPr>
+          <p:cNvPr id="2" name="TextBox 1"/>
+          <p:cNvSpPr txBox="1"/>
+          <p:nvPr/>
+        </p:nvSpPr>
+        <p:spPr>
+          <a:xfrm>
+            <a:off x="822960" y="640080"/>
+            <a:ext cx="10515600" cy="1188720"/>
+          </a:xfrm>
+          <a:prstGeom prst="rect">
+            <a:avLst/>
+          </a:prstGeom>
+          <a:noFill/>
+        </p:spPr>
+        <p:txBody>
+          <a:bodyPr wrap="square" lIns="0" tIns="0" rIns="0" bIns="0">
+            <a:spAutoFit/>
+          </a:bodyPr>
+          <a:lstStyle/>
+          <a:p>
+            <a:pPr>
+              <a:defRPr sz="3600" b="1">
+                <a:solidFill>
+                  <a:srgbClr val="171A18"/>
+                </a:solidFill>
+                <a:latin typeface="Plus Jakarta Sans"/>
+              </a:defRPr>
+            </a:pPr>
+            <a:r>
+              <a:t>Free AI Models: Zero Cost for Students</a:t>
+            </a:r>
+          </a:p>
+          <a:p>
+            <a:pPr>
+              <a:spcBef>
+                <a:spcPts val="600"/>
+              </a:spcBef>
+              <a:defRPr sz="1700">
+                <a:solidFill>
+                  <a:srgbClr val="526058"/>
+                </a:solidFill>
+                <a:latin typeface="Plus Jakarta Sans"/>
+              </a:defRPr>
+            </a:pPr>
+            <a:r>
+              <a:t>Practical options you can use tonight without paying for subscriptions.</a:t>
+            </a:r>
+          </a:p>
+        </p:txBody>
+      </p:sp>
+      <p:sp>
+        <p:nvSpPr>
+          <p:cNvPr id="3" name="TextBox 2"/>
+          <p:cNvSpPr txBox="1"/>
+          <p:nvPr/>
+        </p:nvSpPr>
+        <p:spPr>
+          <a:xfrm>
+            <a:off x="822960" y="2103120"/>
+            <a:ext cx="5029200" cy="4114800"/>
+          </a:xfrm>
+          <a:prstGeom prst="rect">
+            <a:avLst/>
+          </a:prstGeom>
+          <a:noFill/>
+        </p:spPr>
+        <p:txBody>
+          <a:bodyPr wrap="square">
+            <a:spAutoFit/>
+          </a:bodyPr>
+          <a:lstStyle/>
+          <a:p>
+            <a:pPr>
+              <a:defRPr sz="2000" b="1">
+                <a:solidFill>
+                  <a:srgbClr val="1F6B4F"/>
+                </a:solidFill>
+                <a:latin typeface="Plus Jakarta Sans"/>
+              </a:defRPr>
+            </a:pPr>
+            <a:r>
+              <a:t>Free Cloud APIs</a:t>
+            </a:r>
+          </a:p>
+          <a:p>
+            <a:pPr>
+              <a:spcBef>
+                <a:spcPts val="1400"/>
+              </a:spcBef>
+            </a:pPr>
+            <a:r>
+              <a:rPr sz="1000">
+                <a:solidFill>
+                  <a:srgbClr val="1F6B4F"/>
+                </a:solidFill>
+                <a:latin typeface="Plus Jakarta Sans"/>
+              </a:rPr>
+              <a:t>■  </a:t>
+            </a:r>
+            <a:r>
+              <a:rPr sz="1500" b="1">
+                <a:solidFill>
+                  <a:srgbClr val="171A18"/>
+                </a:solidFill>
+                <a:latin typeface="Plus Jakarta Sans"/>
+              </a:rPr>
+              <a:t>Google Gemini API:
+</a:t>
+            </a:r>
+            <a:r>
+              <a:rPr sz="1400">
+                <a:solidFill>
+                  <a:srgbClr val="526058"/>
+                </a:solidFill>
+                <a:latin typeface="Plus Jakarta Sans"/>
+              </a:rPr>
+              <a:t>   Sign in to aistudio.google.com for a free key. Generous free limits for fast coding models.</a:t>
+            </a:r>
+          </a:p>
+          <a:p>
+            <a:pPr>
+              <a:spcBef>
+                <a:spcPts val="1400"/>
+              </a:spcBef>
+            </a:pPr>
+            <a:r>
+              <a:rPr sz="1000">
+                <a:solidFill>
+                  <a:srgbClr val="1F6B4F"/>
+                </a:solidFill>
+                <a:latin typeface="Plus Jakarta Sans"/>
+              </a:rPr>
+              <a:t>■  </a:t>
+            </a:r>
+            <a:r>
+              <a:rPr sz="1500" b="1">
+                <a:solidFill>
+                  <a:srgbClr val="171A18"/>
+                </a:solidFill>
+                <a:latin typeface="Plus Jakarta Sans"/>
+              </a:rPr>
+              <a:t>Groq Cloud:
+</a:t>
+            </a:r>
+            <a:r>
+              <a:rPr sz="1400">
+                <a:solidFill>
+                  <a:srgbClr val="526058"/>
+                </a:solidFill>
+                <a:latin typeface="Plus Jakarta Sans"/>
+              </a:rPr>
+              <a:t>   Ultra-fast free inference on open models like Llama 3.3 via console.groq.com.</a:t>
+            </a:r>
+          </a:p>
+          <a:p>
+            <a:pPr>
+              <a:spcBef>
+                <a:spcPts val="1400"/>
+              </a:spcBef>
+            </a:pPr>
+            <a:r>
+              <a:rPr sz="1000">
+                <a:solidFill>
+                  <a:srgbClr val="1F6B4F"/>
+                </a:solidFill>
+                <a:latin typeface="Plus Jakarta Sans"/>
+              </a:rPr>
+              <a:t>■  </a:t>
+            </a:r>
+            <a:r>
+              <a:rPr sz="1500" b="1">
+                <a:solidFill>
+                  <a:srgbClr val="171A18"/>
+                </a:solidFill>
+                <a:latin typeface="Plus Jakarta Sans"/>
+              </a:rPr>
+              <a:t>GitHub Models:
+</a:t>
+            </a:r>
+            <a:r>
+              <a:rPr sz="1400">
+                <a:solidFill>
+                  <a:srgbClr val="526058"/>
+                </a:solidFill>
+                <a:latin typeface="Plus Jakarta Sans"/>
+              </a:rPr>
+              <a:t>   Free student access to preview models inside VS Code and GitHub Codespaces.</a:t>
+            </a:r>
+          </a:p>
+        </p:txBody>
+      </p:sp>
+      <p:sp>
+        <p:nvSpPr>
+          <p:cNvPr id="4" name="TextBox 3"/>
+          <p:cNvSpPr txBox="1"/>
+          <p:nvPr/>
+        </p:nvSpPr>
+        <p:spPr>
+          <a:xfrm>
+            <a:off x="6309360" y="2103120"/>
+            <a:ext cx="5029200" cy="4114800"/>
+          </a:xfrm>
+          <a:prstGeom prst="rect">
+            <a:avLst/>
+          </a:prstGeom>
+          <a:noFill/>
+        </p:spPr>
+        <p:txBody>
+          <a:bodyPr wrap="square">
+            <a:spAutoFit/>
+          </a:bodyPr>
+          <a:lstStyle/>
+          <a:p>
+            <a:pPr>
+              <a:defRPr sz="2000" b="1">
+                <a:solidFill>
+                  <a:srgbClr val="1F6B4F"/>
+                </a:solidFill>
+                <a:latin typeface="Plus Jakarta Sans"/>
+              </a:defRPr>
+            </a:pPr>
+            <a:r>
+              <a:t>100% Offline with Ollama</a:t>
+            </a:r>
+          </a:p>
+          <a:p>
+            <a:pPr>
+              <a:spcBef>
+                <a:spcPts val="1400"/>
+              </a:spcBef>
+            </a:pPr>
+            <a:r>
+              <a:rPr sz="1000">
+                <a:solidFill>
+                  <a:srgbClr val="1F6B4F"/>
+                </a:solidFill>
+                <a:latin typeface="Plus Jakarta Sans"/>
+              </a:rPr>
+              <a:t>■  </a:t>
+            </a:r>
+            <a:r>
+              <a:rPr sz="1500" b="1">
+                <a:solidFill>
+                  <a:srgbClr val="171A18"/>
+                </a:solidFill>
+                <a:latin typeface="Plus Jakarta Sans"/>
+              </a:rPr>
+              <a:t>Private &amp; Local:
+</a:t>
+            </a:r>
+            <a:r>
+              <a:rPr sz="1400">
+                <a:solidFill>
+                  <a:srgbClr val="526058"/>
+                </a:solidFill>
+                <a:latin typeface="Plus Jakarta Sans"/>
+              </a:rPr>
+              <a:t>   Download ollama.com. Runs entirely on your laptop hardware without needing internet.</a:t>
+            </a:r>
+          </a:p>
+          <a:p>
+            <a:pPr>
+              <a:spcBef>
+                <a:spcPts val="1400"/>
+              </a:spcBef>
+            </a:pPr>
+            <a:r>
+              <a:rPr sz="1000">
+                <a:solidFill>
+                  <a:srgbClr val="1F6B4F"/>
+                </a:solidFill>
+                <a:latin typeface="Plus Jakarta Sans"/>
+              </a:rPr>
+              <a:t>■  </a:t>
+            </a:r>
+            <a:r>
+              <a:rPr sz="1500" b="1">
+                <a:solidFill>
+                  <a:srgbClr val="171A18"/>
+                </a:solidFill>
+                <a:latin typeface="Plus Jakarta Sans"/>
+              </a:rPr>
+              <a:t>Recommended Model:
+</a:t>
+            </a:r>
+            <a:r>
+              <a:rPr sz="1400">
+                <a:solidFill>
+                  <a:srgbClr val="526058"/>
+                </a:solidFill>
+                <a:latin typeface="Plus Jakarta Sans"/>
+              </a:rPr>
+              <a:t>   qwen2.5-coder:7b delivers strong coding reasoning on standard student laptops.</a:t>
+            </a:r>
+          </a:p>
+          <a:p>
+            <a:pPr>
+              <a:spcBef>
+                <a:spcPts val="1400"/>
+              </a:spcBef>
+            </a:pPr>
+            <a:r>
+              <a:rPr sz="1000">
+                <a:solidFill>
+                  <a:srgbClr val="1F6B4F"/>
+                </a:solidFill>
+                <a:latin typeface="Plus Jakarta Sans"/>
+              </a:rPr>
+              <a:t>■  </a:t>
+            </a:r>
+            <a:r>
+              <a:rPr sz="1500" b="1">
+                <a:solidFill>
+                  <a:srgbClr val="171A18"/>
+                </a:solidFill>
+                <a:latin typeface="Plus Jakarta Sans"/>
+              </a:rPr>
+              <a:t>Zero Latency:
+</a:t>
+            </a:r>
+            <a:r>
+              <a:rPr sz="1400">
+                <a:solidFill>
+                  <a:srgbClr val="526058"/>
+                </a:solidFill>
+                <a:latin typeface="Plus Jakarta Sans"/>
+              </a:rPr>
+              <a:t>   Fast responses directly on your machine with complete data privacy.</a:t>
+            </a:r>
+          </a:p>
+        </p:txBody>
+      </p:sp>
+    </p:spTree>
+  </p:cSld>
+  <p:clrMapOvr>
+    <a:masterClrMapping/>
+  </p:clrMapOvr>
+</p:sld>
+</file>
+
+<file path=ppt/slides/slide14.xml><?xml version="1.0" encoding="utf-8"?>
+<p:sld xmlns:a="http://schemas.openxmlformats.org/drawingml/2006/main" xmlns:p="http://schemas.openxmlformats.org/presentationml/2006/main" xmlns:r="http://schemas.openxmlformats.org/officeDocument/2006/relationships">
+  <p:cSld>
+    <p:spTree>
+      <p:nvGrpSpPr>
+        <p:cNvPr id="1" name=""/>
+        <p:cNvGrpSpPr/>
+        <p:nvPr/>
+      </p:nvGrpSpPr>
+      <p:grpSpPr/>
+      <p:sp>
+        <p:nvSpPr>
+          <p:cNvPr id="2" name="TextBox 1"/>
+          <p:cNvSpPr txBox="1"/>
+          <p:nvPr/>
+        </p:nvSpPr>
+        <p:spPr>
+          <a:xfrm>
             <a:off x="1371600" y="731520"/>
             <a:ext cx="9418320" cy="822960"/>
           </a:xfrm>
@@ -3226,7 +4577,7 @@
               </a:defRPr>
             </a:pPr>
             <a:r>
-              <a:t>Reality Check: Learning to Code in 2026</a:t>
+              <a:t>Reality Check: AI Confidence vs Reality</a:t>
             </a:r>
           </a:p>
         </p:txBody>
@@ -3281,7 +4632,7 @@
               </a:defRPr>
             </a:pPr>
             <a:r>
-              <a:t>[MEME 03 PLACEHOLDER: 400 Pages of Docs vs Writing Clean Specs]</a:t>
+              <a:t>[MEME 04: AI confidently saying 'all bugs fixed' vs Clicking the button and the console explodes]</a:t>
             </a:r>
           </a:p>
           <a:p>
@@ -3333,1281 +4684,7 @@
               </a:defRPr>
             </a:pPr>
             <a:r>
-              <a:t>Reading 200 pages of manual documentation at 3:00 AM is officially a thing of the past. Define the requirements and let the tools execute.</a:t>
-            </a:r>
-          </a:p>
-        </p:txBody>
-      </p:sp>
-    </p:spTree>
-  </p:cSld>
-  <p:clrMapOvr>
-    <a:masterClrMapping/>
-  </p:clrMapOvr>
-</p:sld>
-</file>
-
-<file path=ppt/slides/slide11.xml><?xml version="1.0" encoding="utf-8"?>
-<p:sld xmlns:a="http://schemas.openxmlformats.org/drawingml/2006/main" xmlns:p="http://schemas.openxmlformats.org/presentationml/2006/main" xmlns:r="http://schemas.openxmlformats.org/officeDocument/2006/relationships">
-  <p:cSld>
-    <p:spTree>
-      <p:nvGrpSpPr>
-        <p:cNvPr id="1" name=""/>
-        <p:cNvGrpSpPr/>
-        <p:nvPr/>
-      </p:nvGrpSpPr>
-      <p:grpSpPr/>
-      <p:sp>
-        <p:nvSpPr>
-          <p:cNvPr id="2" name="TextBox 1"/>
-          <p:cNvSpPr txBox="1"/>
-          <p:nvPr/>
-        </p:nvSpPr>
-        <p:spPr>
-          <a:xfrm>
-            <a:off x="822960" y="640080"/>
-            <a:ext cx="10515600" cy="1188720"/>
-          </a:xfrm>
-          <a:prstGeom prst="rect">
-            <a:avLst/>
-          </a:prstGeom>
-          <a:noFill/>
-        </p:spPr>
-        <p:txBody>
-          <a:bodyPr wrap="square" lIns="0" tIns="0" rIns="0" bIns="0">
-            <a:spAutoFit/>
-          </a:bodyPr>
-          <a:lstStyle/>
-          <a:p>
-            <a:pPr>
-              <a:defRPr sz="3600" b="1">
-                <a:solidFill>
-                  <a:srgbClr val="171A18"/>
-                </a:solidFill>
-                <a:latin typeface="Plus Jakarta Sans"/>
-              </a:defRPr>
-            </a:pPr>
-            <a:r>
-              <a:t>How the Autonomous Coding Loop Works</a:t>
-            </a:r>
-          </a:p>
-          <a:p>
-            <a:pPr>
-              <a:spcBef>
-                <a:spcPts val="600"/>
-              </a:spcBef>
-              <a:defRPr sz="1700">
-                <a:solidFill>
-                  <a:srgbClr val="526058"/>
-                </a:solidFill>
-                <a:latin typeface="Plus Jakarta Sans"/>
-              </a:defRPr>
-            </a:pPr>
-            <a:r>
-              <a:t>Not a chatbot copying snippets, but an automated cycle that creates and tests code.</a:t>
-            </a:r>
-          </a:p>
-        </p:txBody>
-      </p:sp>
-      <p:sp>
-        <p:nvSpPr>
-          <p:cNvPr id="3" name="Rectangle 2"/>
-          <p:cNvSpPr/>
-          <p:nvPr/>
-        </p:nvSpPr>
-        <p:spPr>
-          <a:xfrm>
-            <a:off x="822960" y="2286000"/>
-            <a:ext cx="2514600" cy="3474720"/>
-          </a:xfrm>
-          <a:prstGeom prst="rect">
-            <a:avLst/>
-          </a:prstGeom>
-          <a:solidFill>
-            <a:srgbClr val="F8FAF8"/>
-          </a:solidFill>
-          <a:ln w="12700">
-            <a:solidFill>
-              <a:srgbClr val="E2E8E0"/>
-            </a:solidFill>
-          </a:ln>
-        </p:spPr>
-        <p:style>
-          <a:lnRef idx="1">
-            <a:schemeClr val="accent1"/>
-          </a:lnRef>
-          <a:fillRef idx="3">
-            <a:schemeClr val="accent1"/>
-          </a:fillRef>
-          <a:effectRef idx="2">
-            <a:schemeClr val="accent1"/>
-          </a:effectRef>
-          <a:fontRef idx="minor">
-            <a:schemeClr val="lt1"/>
-          </a:fontRef>
-        </p:style>
-        <p:txBody>
-          <a:bodyPr rtlCol="0" anchor="ctr" wrap="square"/>
-          <a:lstStyle/>
-          <a:p>
-            <a:pPr algn="ctr">
-              <a:defRPr sz="1100" b="1">
-                <a:solidFill>
-                  <a:srgbClr val="1F6B4F"/>
-                </a:solidFill>
-                <a:latin typeface="JetBrains Mono"/>
-              </a:defRPr>
-            </a:pPr>
-            <a:r>
-              <a:t>STAGE 01</a:t>
-            </a:r>
-          </a:p>
-          <a:p>
-            <a:pPr>
-              <a:spcBef>
-                <a:spcPts val="600"/>
-              </a:spcBef>
-              <a:defRPr sz="1700" b="1">
-                <a:solidFill>
-                  <a:srgbClr val="171A18"/>
-                </a:solidFill>
-                <a:latin typeface="Plus Jakarta Sans"/>
-              </a:defRPr>
-            </a:pPr>
-            <a:r>
-              <a:t>Define the Goal</a:t>
-            </a:r>
-          </a:p>
-          <a:p>
-            <a:pPr>
-              <a:spcBef>
-                <a:spcPts val="1200"/>
-              </a:spcBef>
-              <a:defRPr sz="1300">
-                <a:solidFill>
-                  <a:srgbClr val="526058"/>
-                </a:solidFill>
-                <a:latin typeface="Plus Jakarta Sans"/>
-              </a:defRPr>
-            </a:pPr>
-            <a:r>
-              <a:t>Write clear requirements, design rules, and data structures in a simple specification document.</a:t>
-            </a:r>
-          </a:p>
-        </p:txBody>
-      </p:sp>
-      <p:sp>
-        <p:nvSpPr>
-          <p:cNvPr id="4" name="Rectangle 3"/>
-          <p:cNvSpPr/>
-          <p:nvPr/>
-        </p:nvSpPr>
-        <p:spPr>
-          <a:xfrm>
-            <a:off x="3520440" y="2286000"/>
-            <a:ext cx="2514600" cy="3474720"/>
-          </a:xfrm>
-          <a:prstGeom prst="rect">
-            <a:avLst/>
-          </a:prstGeom>
-          <a:solidFill>
-            <a:srgbClr val="F8FAF8"/>
-          </a:solidFill>
-          <a:ln w="12700">
-            <a:solidFill>
-              <a:srgbClr val="E2E8E0"/>
-            </a:solidFill>
-          </a:ln>
-        </p:spPr>
-        <p:style>
-          <a:lnRef idx="1">
-            <a:schemeClr val="accent1"/>
-          </a:lnRef>
-          <a:fillRef idx="3">
-            <a:schemeClr val="accent1"/>
-          </a:fillRef>
-          <a:effectRef idx="2">
-            <a:schemeClr val="accent1"/>
-          </a:effectRef>
-          <a:fontRef idx="minor">
-            <a:schemeClr val="lt1"/>
-          </a:fontRef>
-        </p:style>
-        <p:txBody>
-          <a:bodyPr rtlCol="0" anchor="ctr" wrap="square"/>
-          <a:lstStyle/>
-          <a:p>
-            <a:pPr algn="ctr">
-              <a:defRPr sz="1100" b="1">
-                <a:solidFill>
-                  <a:srgbClr val="1F6B4F"/>
-                </a:solidFill>
-                <a:latin typeface="JetBrains Mono"/>
-              </a:defRPr>
-            </a:pPr>
-            <a:r>
-              <a:t>STAGE 02</a:t>
-            </a:r>
-          </a:p>
-          <a:p>
-            <a:pPr>
-              <a:spcBef>
-                <a:spcPts val="600"/>
-              </a:spcBef>
-              <a:defRPr sz="1700" b="1">
-                <a:solidFill>
-                  <a:srgbClr val="171A18"/>
-                </a:solidFill>
-                <a:latin typeface="Plus Jakarta Sans"/>
-              </a:defRPr>
-            </a:pPr>
-            <a:r>
-              <a:t>Autonomous Edit</a:t>
-            </a:r>
-          </a:p>
-          <a:p>
-            <a:pPr>
-              <a:spcBef>
-                <a:spcPts val="1200"/>
-              </a:spcBef>
-              <a:defRPr sz="1300">
-                <a:solidFill>
-                  <a:srgbClr val="526058"/>
-                </a:solidFill>
-                <a:latin typeface="Plus Jakarta Sans"/>
-              </a:defRPr>
-            </a:pPr>
-            <a:r>
-              <a:t>The agent reads existing files, writes modular components, and links application routes.</a:t>
-            </a:r>
-          </a:p>
-        </p:txBody>
-      </p:sp>
-      <p:sp>
-        <p:nvSpPr>
-          <p:cNvPr id="5" name="Rectangle 4"/>
-          <p:cNvSpPr/>
-          <p:nvPr/>
-        </p:nvSpPr>
-        <p:spPr>
-          <a:xfrm>
-            <a:off x="6217920" y="2286000"/>
-            <a:ext cx="2514600" cy="3474720"/>
-          </a:xfrm>
-          <a:prstGeom prst="rect">
-            <a:avLst/>
-          </a:prstGeom>
-          <a:solidFill>
-            <a:srgbClr val="F8FAF8"/>
-          </a:solidFill>
-          <a:ln w="12700">
-            <a:solidFill>
-              <a:srgbClr val="E2E8E0"/>
-            </a:solidFill>
-          </a:ln>
-        </p:spPr>
-        <p:style>
-          <a:lnRef idx="1">
-            <a:schemeClr val="accent1"/>
-          </a:lnRef>
-          <a:fillRef idx="3">
-            <a:schemeClr val="accent1"/>
-          </a:fillRef>
-          <a:effectRef idx="2">
-            <a:schemeClr val="accent1"/>
-          </a:effectRef>
-          <a:fontRef idx="minor">
-            <a:schemeClr val="lt1"/>
-          </a:fontRef>
-        </p:style>
-        <p:txBody>
-          <a:bodyPr rtlCol="0" anchor="ctr" wrap="square"/>
-          <a:lstStyle/>
-          <a:p>
-            <a:pPr algn="ctr">
-              <a:defRPr sz="1100" b="1">
-                <a:solidFill>
-                  <a:srgbClr val="1F6B4F"/>
-                </a:solidFill>
-                <a:latin typeface="JetBrains Mono"/>
-              </a:defRPr>
-            </a:pPr>
-            <a:r>
-              <a:t>STAGE 03</a:t>
-            </a:r>
-          </a:p>
-          <a:p>
-            <a:pPr>
-              <a:spcBef>
-                <a:spcPts val="600"/>
-              </a:spcBef>
-              <a:defRPr sz="1700" b="1">
-                <a:solidFill>
-                  <a:srgbClr val="171A18"/>
-                </a:solidFill>
-                <a:latin typeface="Plus Jakarta Sans"/>
-              </a:defRPr>
-            </a:pPr>
-            <a:r>
-              <a:t>Automated Check</a:t>
-            </a:r>
-          </a:p>
-          <a:p>
-            <a:pPr>
-              <a:spcBef>
-                <a:spcPts val="1200"/>
-              </a:spcBef>
-              <a:defRPr sz="1300">
-                <a:solidFill>
-                  <a:srgbClr val="526058"/>
-                </a:solidFill>
-                <a:latin typeface="Plus Jakarta Sans"/>
-              </a:defRPr>
-            </a:pPr>
-            <a:r>
-              <a:t>Automated tools build the code. If an error appears, the agent reads terminal output and fixes it.</a:t>
-            </a:r>
-          </a:p>
-        </p:txBody>
-      </p:sp>
-      <p:sp>
-        <p:nvSpPr>
-          <p:cNvPr id="6" name="Rectangle 5"/>
-          <p:cNvSpPr/>
-          <p:nvPr/>
-        </p:nvSpPr>
-        <p:spPr>
-          <a:xfrm>
-            <a:off x="8915400" y="2286000"/>
-            <a:ext cx="2514600" cy="3474720"/>
-          </a:xfrm>
-          <a:prstGeom prst="rect">
-            <a:avLst/>
-          </a:prstGeom>
-          <a:solidFill>
-            <a:srgbClr val="F8FAF8"/>
-          </a:solidFill>
-          <a:ln w="12700">
-            <a:solidFill>
-              <a:srgbClr val="E2E8E0"/>
-            </a:solidFill>
-          </a:ln>
-        </p:spPr>
-        <p:style>
-          <a:lnRef idx="1">
-            <a:schemeClr val="accent1"/>
-          </a:lnRef>
-          <a:fillRef idx="3">
-            <a:schemeClr val="accent1"/>
-          </a:fillRef>
-          <a:effectRef idx="2">
-            <a:schemeClr val="accent1"/>
-          </a:effectRef>
-          <a:fontRef idx="minor">
-            <a:schemeClr val="lt1"/>
-          </a:fontRef>
-        </p:style>
-        <p:txBody>
-          <a:bodyPr rtlCol="0" anchor="ctr" wrap="square"/>
-          <a:lstStyle/>
-          <a:p>
-            <a:pPr algn="ctr">
-              <a:defRPr sz="1100" b="1">
-                <a:solidFill>
-                  <a:srgbClr val="1F6B4F"/>
-                </a:solidFill>
-                <a:latin typeface="JetBrains Mono"/>
-              </a:defRPr>
-            </a:pPr>
-            <a:r>
-              <a:t>STAGE 04</a:t>
-            </a:r>
-          </a:p>
-          <a:p>
-            <a:pPr>
-              <a:spcBef>
-                <a:spcPts val="600"/>
-              </a:spcBef>
-              <a:defRPr sz="1700" b="1">
-                <a:solidFill>
-                  <a:srgbClr val="171A18"/>
-                </a:solidFill>
-                <a:latin typeface="Plus Jakarta Sans"/>
-              </a:defRPr>
-            </a:pPr>
-            <a:r>
-              <a:t>Safe History</a:t>
-            </a:r>
-          </a:p>
-          <a:p>
-            <a:pPr>
-              <a:spcBef>
-                <a:spcPts val="1200"/>
-              </a:spcBef>
-              <a:defRPr sz="1300">
-                <a:solidFill>
-                  <a:srgbClr val="526058"/>
-                </a:solidFill>
-                <a:latin typeface="Plus Jakarta Sans"/>
-              </a:defRPr>
-            </a:pPr>
-            <a:r>
-              <a:t>Every successful step is saved into version control, allowing you to experiment freely with zero risk.</a:t>
-            </a:r>
-          </a:p>
-        </p:txBody>
-      </p:sp>
-    </p:spTree>
-  </p:cSld>
-  <p:clrMapOvr>
-    <a:masterClrMapping/>
-  </p:clrMapOvr>
-</p:sld>
-</file>
-
-<file path=ppt/slides/slide12.xml><?xml version="1.0" encoding="utf-8"?>
-<p:sld xmlns:a="http://schemas.openxmlformats.org/drawingml/2006/main" xmlns:p="http://schemas.openxmlformats.org/presentationml/2006/main" xmlns:r="http://schemas.openxmlformats.org/officeDocument/2006/relationships">
-  <p:cSld>
-    <p:spTree>
-      <p:nvGrpSpPr>
-        <p:cNvPr id="1" name=""/>
-        <p:cNvGrpSpPr/>
-        <p:nvPr/>
-      </p:nvGrpSpPr>
-      <p:grpSpPr/>
-      <p:sp>
-        <p:nvSpPr>
-          <p:cNvPr id="2" name="TextBox 1"/>
-          <p:cNvSpPr txBox="1"/>
-          <p:nvPr/>
-        </p:nvSpPr>
-        <p:spPr>
-          <a:xfrm>
-            <a:off x="822960" y="640080"/>
-            <a:ext cx="10515600" cy="1188720"/>
-          </a:xfrm>
-          <a:prstGeom prst="rect">
-            <a:avLst/>
-          </a:prstGeom>
-          <a:noFill/>
-        </p:spPr>
-        <p:txBody>
-          <a:bodyPr wrap="square" lIns="0" tIns="0" rIns="0" bIns="0">
-            <a:spAutoFit/>
-          </a:bodyPr>
-          <a:lstStyle/>
-          <a:p>
-            <a:pPr>
-              <a:defRPr sz="3600" b="1">
-                <a:solidFill>
-                  <a:srgbClr val="171A18"/>
-                </a:solidFill>
-                <a:latin typeface="Plus Jakarta Sans"/>
-              </a:defRPr>
-            </a:pPr>
-            <a:r>
-              <a:t>Introducing OpenCode</a:t>
-            </a:r>
-          </a:p>
-          <a:p>
-            <a:pPr>
-              <a:spcBef>
-                <a:spcPts val="600"/>
-              </a:spcBef>
-              <a:defRPr sz="1700">
-                <a:solidFill>
-                  <a:srgbClr val="526058"/>
-                </a:solidFill>
-                <a:latin typeface="Plus Jakarta Sans"/>
-              </a:defRPr>
-            </a:pPr>
-            <a:r>
-              <a:t>An open-source autonomous coding agent that runs directly in your terminal.</a:t>
-            </a:r>
-          </a:p>
-        </p:txBody>
-      </p:sp>
-      <p:sp>
-        <p:nvSpPr>
-          <p:cNvPr id="3" name="TextBox 2"/>
-          <p:cNvSpPr txBox="1"/>
-          <p:nvPr/>
-        </p:nvSpPr>
-        <p:spPr>
-          <a:xfrm>
-            <a:off x="822960" y="2103120"/>
-            <a:ext cx="5120640" cy="4114800"/>
-          </a:xfrm>
-          <a:prstGeom prst="rect">
-            <a:avLst/>
-          </a:prstGeom>
-          <a:noFill/>
-        </p:spPr>
-        <p:txBody>
-          <a:bodyPr wrap="square">
-            <a:spAutoFit/>
-          </a:bodyPr>
-          <a:lstStyle/>
-          <a:p>
-            <a:pPr>
-              <a:defRPr sz="2000" b="1">
-                <a:solidFill>
-                  <a:srgbClr val="1F6B4F"/>
-                </a:solidFill>
-                <a:latin typeface="Plus Jakarta Sans"/>
-              </a:defRPr>
-            </a:pPr>
-            <a:r>
-              <a:t>Why OpenCode?</a:t>
-            </a:r>
-          </a:p>
-          <a:p>
-            <a:pPr>
-              <a:spcBef>
-                <a:spcPts val="1400"/>
-              </a:spcBef>
-            </a:pPr>
-            <a:r>
-              <a:rPr sz="1000">
-                <a:solidFill>
-                  <a:srgbClr val="1F6B4F"/>
-                </a:solidFill>
-                <a:latin typeface="Plus Jakarta Sans"/>
-              </a:rPr>
-              <a:t>■  </a:t>
-            </a:r>
-            <a:r>
-              <a:rPr sz="1500" b="1">
-                <a:solidFill>
-                  <a:srgbClr val="171A18"/>
-                </a:solidFill>
-                <a:latin typeface="Plus Jakarta Sans"/>
-              </a:rPr>
-              <a:t>100% Open Source:
-</a:t>
-            </a:r>
-            <a:r>
-              <a:rPr sz="1400">
-                <a:solidFill>
-                  <a:srgbClr val="526058"/>
-                </a:solidFill>
-                <a:latin typeface="Plus Jakarta Sans"/>
-              </a:rPr>
-              <a:t>   Maintained by Anomaly (GitHub: anomalyco/opencode). Free to use with zero vendor lock-in.</a:t>
-            </a:r>
-          </a:p>
-          <a:p>
-            <a:pPr>
-              <a:spcBef>
-                <a:spcPts val="1400"/>
-              </a:spcBef>
-            </a:pPr>
-            <a:r>
-              <a:rPr sz="1000">
-                <a:solidFill>
-                  <a:srgbClr val="1F6B4F"/>
-                </a:solidFill>
-                <a:latin typeface="Plus Jakarta Sans"/>
-              </a:rPr>
-              <a:t>■  </a:t>
-            </a:r>
-            <a:r>
-              <a:rPr sz="1500" b="1">
-                <a:solidFill>
-                  <a:srgbClr val="171A18"/>
-                </a:solidFill>
-                <a:latin typeface="Plus Jakarta Sans"/>
-              </a:rPr>
-              <a:t>Dual Execution Modes:
-</a:t>
-            </a:r>
-            <a:r>
-              <a:rPr sz="1400">
-                <a:solidFill>
-                  <a:srgbClr val="526058"/>
-                </a:solidFill>
-                <a:latin typeface="Plus Jakarta Sans"/>
-              </a:rPr>
-              <a:t>   Plan Mode surveys your architecture without editing; Build Mode autonomously edits files and runs tests.</a:t>
-            </a:r>
-          </a:p>
-          <a:p>
-            <a:pPr>
-              <a:spcBef>
-                <a:spcPts val="1400"/>
-              </a:spcBef>
-            </a:pPr>
-            <a:r>
-              <a:rPr sz="1000">
-                <a:solidFill>
-                  <a:srgbClr val="1F6B4F"/>
-                </a:solidFill>
-                <a:latin typeface="Plus Jakarta Sans"/>
-              </a:rPr>
-              <a:t>■  </a:t>
-            </a:r>
-            <a:r>
-              <a:rPr sz="1500" b="1">
-                <a:solidFill>
-                  <a:srgbClr val="171A18"/>
-                </a:solidFill>
-                <a:latin typeface="Plus Jakarta Sans"/>
-              </a:rPr>
-              <a:t>Connects to Any Model:
-</a:t>
-            </a:r>
-            <a:r>
-              <a:rPr sz="1400">
-                <a:solidFill>
-                  <a:srgbClr val="526058"/>
-                </a:solidFill>
-                <a:latin typeface="Plus Jakarta Sans"/>
-              </a:rPr>
-              <a:t>   Works with free cloud endpoints or completely private offline models on your personal computer.</a:t>
-            </a:r>
-          </a:p>
-        </p:txBody>
-      </p:sp>
-      <p:sp>
-        <p:nvSpPr>
-          <p:cNvPr id="4" name="Rectangle 3"/>
-          <p:cNvSpPr/>
-          <p:nvPr/>
-        </p:nvSpPr>
-        <p:spPr>
-          <a:xfrm>
-            <a:off x="6309360" y="2103120"/>
-            <a:ext cx="5029200" cy="3291840"/>
-          </a:xfrm>
-          <a:prstGeom prst="rect">
-            <a:avLst/>
-          </a:prstGeom>
-          <a:solidFill>
-            <a:srgbClr val="F8FAF8"/>
-          </a:solidFill>
-          <a:ln w="19050">
-            <a:solidFill>
-              <a:srgbClr val="1F6B4F"/>
-            </a:solidFill>
-          </a:ln>
-        </p:spPr>
-        <p:style>
-          <a:lnRef idx="1">
-            <a:schemeClr val="accent1"/>
-          </a:lnRef>
-          <a:fillRef idx="3">
-            <a:schemeClr val="accent1"/>
-          </a:fillRef>
-          <a:effectRef idx="2">
-            <a:schemeClr val="accent1"/>
-          </a:effectRef>
-          <a:fontRef idx="minor">
-            <a:schemeClr val="lt1"/>
-          </a:fontRef>
-        </p:style>
-        <p:txBody>
-          <a:bodyPr rtlCol="0" anchor="ctr" wrap="square"/>
-          <a:lstStyle/>
-          <a:p>
-            <a:pPr algn="ctr">
-              <a:defRPr sz="1300">
-                <a:solidFill>
-                  <a:srgbClr val="526058"/>
-                </a:solidFill>
-                <a:latin typeface="JetBrains Mono"/>
-              </a:defRPr>
-            </a:pPr>
-            <a:r>
-              <a:t>// Quick Installation in 60 Seconds</a:t>
-            </a:r>
-          </a:p>
-          <a:p>
-            <a:pPr>
-              <a:spcBef>
-                <a:spcPts val="800"/>
-              </a:spcBef>
-              <a:defRPr sz="1400" b="1">
-                <a:solidFill>
-                  <a:srgbClr val="1F6B4F"/>
-                </a:solidFill>
-                <a:latin typeface="JetBrains Mono"/>
-              </a:defRPr>
-            </a:pPr>
-            <a:r>
-              <a:t>$ npm install -g @opencode/cli</a:t>
-            </a:r>
-          </a:p>
-          <a:p>
-            <a:pPr>
-              <a:spcBef>
-                <a:spcPts val="800"/>
-              </a:spcBef>
-              <a:defRPr sz="1400" b="1">
-                <a:solidFill>
-                  <a:srgbClr val="1F6B4F"/>
-                </a:solidFill>
-                <a:latin typeface="JetBrains Mono"/>
-              </a:defRPr>
-            </a:pPr>
-            <a:r>
-              <a:t>$ cd ./my-project</a:t>
-            </a:r>
-          </a:p>
-          <a:p>
-            <a:pPr>
-              <a:spcBef>
-                <a:spcPts val="800"/>
-              </a:spcBef>
-              <a:defRPr sz="1400" b="1">
-                <a:solidFill>
-                  <a:srgbClr val="1F6B4F"/>
-                </a:solidFill>
-                <a:latin typeface="JetBrains Mono"/>
-              </a:defRPr>
-            </a:pPr>
-            <a:r>
-              <a:t>$ opencode</a:t>
-            </a:r>
-          </a:p>
-          <a:p>
-            <a:pPr>
-              <a:spcBef>
-                <a:spcPts val="800"/>
-              </a:spcBef>
-              <a:defRPr sz="1400" b="1">
-                <a:solidFill>
-                  <a:srgbClr val="526058"/>
-                </a:solidFill>
-                <a:latin typeface="JetBrains Mono"/>
-              </a:defRPr>
-            </a:pPr>
-          </a:p>
-          <a:p>
-            <a:pPr>
-              <a:spcBef>
-                <a:spcPts val="800"/>
-              </a:spcBef>
-              <a:defRPr sz="1400" b="1">
-                <a:solidFill>
-                  <a:srgbClr val="526058"/>
-                </a:solidFill>
-                <a:latin typeface="JetBrains Mono"/>
-              </a:defRPr>
-            </a:pPr>
-            <a:r>
-              <a:t>// Runs on macOS, Linux, and Windows WSL</a:t>
-            </a:r>
-          </a:p>
-        </p:txBody>
-      </p:sp>
-    </p:spTree>
-  </p:cSld>
-  <p:clrMapOvr>
-    <a:masterClrMapping/>
-  </p:clrMapOvr>
-</p:sld>
-</file>
-
-<file path=ppt/slides/slide13.xml><?xml version="1.0" encoding="utf-8"?>
-<p:sld xmlns:a="http://schemas.openxmlformats.org/drawingml/2006/main" xmlns:p="http://schemas.openxmlformats.org/presentationml/2006/main" xmlns:r="http://schemas.openxmlformats.org/officeDocument/2006/relationships">
-  <p:cSld>
-    <p:spTree>
-      <p:nvGrpSpPr>
-        <p:cNvPr id="1" name=""/>
-        <p:cNvGrpSpPr/>
-        <p:nvPr/>
-      </p:nvGrpSpPr>
-      <p:grpSpPr/>
-      <p:sp>
-        <p:nvSpPr>
-          <p:cNvPr id="2" name="TextBox 1"/>
-          <p:cNvSpPr txBox="1"/>
-          <p:nvPr/>
-        </p:nvSpPr>
-        <p:spPr>
-          <a:xfrm>
-            <a:off x="822960" y="640080"/>
-            <a:ext cx="10515600" cy="1188720"/>
-          </a:xfrm>
-          <a:prstGeom prst="rect">
-            <a:avLst/>
-          </a:prstGeom>
-          <a:noFill/>
-        </p:spPr>
-        <p:txBody>
-          <a:bodyPr wrap="square" lIns="0" tIns="0" rIns="0" bIns="0">
-            <a:spAutoFit/>
-          </a:bodyPr>
-          <a:lstStyle/>
-          <a:p>
-            <a:pPr>
-              <a:defRPr sz="3600" b="1">
-                <a:solidFill>
-                  <a:srgbClr val="171A18"/>
-                </a:solidFill>
-                <a:latin typeface="Plus Jakarta Sans"/>
-              </a:defRPr>
-            </a:pPr>
-            <a:r>
-              <a:t>Free AI Models: Zero Cost for Students</a:t>
-            </a:r>
-          </a:p>
-          <a:p>
-            <a:pPr>
-              <a:spcBef>
-                <a:spcPts val="600"/>
-              </a:spcBef>
-              <a:defRPr sz="1700">
-                <a:solidFill>
-                  <a:srgbClr val="526058"/>
-                </a:solidFill>
-                <a:latin typeface="Plus Jakarta Sans"/>
-              </a:defRPr>
-            </a:pPr>
-            <a:r>
-              <a:t>Practical options you can use tonight without paying for subscriptions.</a:t>
-            </a:r>
-          </a:p>
-        </p:txBody>
-      </p:sp>
-      <p:sp>
-        <p:nvSpPr>
-          <p:cNvPr id="3" name="TextBox 2"/>
-          <p:cNvSpPr txBox="1"/>
-          <p:nvPr/>
-        </p:nvSpPr>
-        <p:spPr>
-          <a:xfrm>
-            <a:off x="822960" y="2103120"/>
-            <a:ext cx="5029200" cy="4114800"/>
-          </a:xfrm>
-          <a:prstGeom prst="rect">
-            <a:avLst/>
-          </a:prstGeom>
-          <a:noFill/>
-        </p:spPr>
-        <p:txBody>
-          <a:bodyPr wrap="square">
-            <a:spAutoFit/>
-          </a:bodyPr>
-          <a:lstStyle/>
-          <a:p>
-            <a:pPr>
-              <a:defRPr sz="2000" b="1">
-                <a:solidFill>
-                  <a:srgbClr val="1F6B4F"/>
-                </a:solidFill>
-                <a:latin typeface="Plus Jakarta Sans"/>
-              </a:defRPr>
-            </a:pPr>
-            <a:r>
-              <a:t>Free Cloud APIs</a:t>
-            </a:r>
-          </a:p>
-          <a:p>
-            <a:pPr>
-              <a:spcBef>
-                <a:spcPts val="1400"/>
-              </a:spcBef>
-            </a:pPr>
-            <a:r>
-              <a:rPr sz="1000">
-                <a:solidFill>
-                  <a:srgbClr val="1F6B4F"/>
-                </a:solidFill>
-                <a:latin typeface="Plus Jakarta Sans"/>
-              </a:rPr>
-              <a:t>■  </a:t>
-            </a:r>
-            <a:r>
-              <a:rPr sz="1500" b="1">
-                <a:solidFill>
-                  <a:srgbClr val="171A18"/>
-                </a:solidFill>
-                <a:latin typeface="Plus Jakarta Sans"/>
-              </a:rPr>
-              <a:t>Google Gemini API:
-</a:t>
-            </a:r>
-            <a:r>
-              <a:rPr sz="1400">
-                <a:solidFill>
-                  <a:srgbClr val="526058"/>
-                </a:solidFill>
-                <a:latin typeface="Plus Jakarta Sans"/>
-              </a:rPr>
-              <a:t>   Sign in to aistudio.google.com for a free key. Generous free tiers with Gemini 1.5 Flash and Gemini 2.0.</a:t>
-            </a:r>
-          </a:p>
-          <a:p>
-            <a:pPr>
-              <a:spcBef>
-                <a:spcPts val="1400"/>
-              </a:spcBef>
-            </a:pPr>
-            <a:r>
-              <a:rPr sz="1000">
-                <a:solidFill>
-                  <a:srgbClr val="1F6B4F"/>
-                </a:solidFill>
-                <a:latin typeface="Plus Jakarta Sans"/>
-              </a:rPr>
-              <a:t>■  </a:t>
-            </a:r>
-            <a:r>
-              <a:rPr sz="1500" b="1">
-                <a:solidFill>
-                  <a:srgbClr val="171A18"/>
-                </a:solidFill>
-                <a:latin typeface="Plus Jakarta Sans"/>
-              </a:rPr>
-              <a:t>Groq Cloud:
-</a:t>
-            </a:r>
-            <a:r>
-              <a:rPr sz="1400">
-                <a:solidFill>
-                  <a:srgbClr val="526058"/>
-                </a:solidFill>
-                <a:latin typeface="Plus Jakarta Sans"/>
-              </a:rPr>
-              <a:t>   Ultra-fast token generation on open-weight models like Llama 3.3 via console.groq.com.</a:t>
-            </a:r>
-          </a:p>
-          <a:p>
-            <a:pPr>
-              <a:spcBef>
-                <a:spcPts val="1400"/>
-              </a:spcBef>
-            </a:pPr>
-            <a:r>
-              <a:rPr sz="1000">
-                <a:solidFill>
-                  <a:srgbClr val="1F6B4F"/>
-                </a:solidFill>
-                <a:latin typeface="Plus Jakarta Sans"/>
-              </a:rPr>
-              <a:t>■  </a:t>
-            </a:r>
-            <a:r>
-              <a:rPr sz="1500" b="1">
-                <a:solidFill>
-                  <a:srgbClr val="171A18"/>
-                </a:solidFill>
-                <a:latin typeface="Plus Jakarta Sans"/>
-              </a:rPr>
-              <a:t>GitHub Models:
-</a:t>
-            </a:r>
-            <a:r>
-              <a:rPr sz="1400">
-                <a:solidFill>
-                  <a:srgbClr val="526058"/>
-                </a:solidFill>
-                <a:latin typeface="Plus Jakarta Sans"/>
-              </a:rPr>
-              <a:t>   Free student access to models like GPT-4o and Claude inside VS Code and GitHub Codespaces.</a:t>
-            </a:r>
-          </a:p>
-        </p:txBody>
-      </p:sp>
-      <p:sp>
-        <p:nvSpPr>
-          <p:cNvPr id="4" name="TextBox 3"/>
-          <p:cNvSpPr txBox="1"/>
-          <p:nvPr/>
-        </p:nvSpPr>
-        <p:spPr>
-          <a:xfrm>
-            <a:off x="6309360" y="2103120"/>
-            <a:ext cx="5029200" cy="4114800"/>
-          </a:xfrm>
-          <a:prstGeom prst="rect">
-            <a:avLst/>
-          </a:prstGeom>
-          <a:noFill/>
-        </p:spPr>
-        <p:txBody>
-          <a:bodyPr wrap="square">
-            <a:spAutoFit/>
-          </a:bodyPr>
-          <a:lstStyle/>
-          <a:p>
-            <a:pPr>
-              <a:defRPr sz="2000" b="1">
-                <a:solidFill>
-                  <a:srgbClr val="1F6B4F"/>
-                </a:solidFill>
-                <a:latin typeface="Plus Jakarta Sans"/>
-              </a:defRPr>
-            </a:pPr>
-            <a:r>
-              <a:t>100% Offline with Ollama</a:t>
-            </a:r>
-          </a:p>
-          <a:p>
-            <a:pPr>
-              <a:spcBef>
-                <a:spcPts val="1400"/>
-              </a:spcBef>
-            </a:pPr>
-            <a:r>
-              <a:rPr sz="1000">
-                <a:solidFill>
-                  <a:srgbClr val="1F6B4F"/>
-                </a:solidFill>
-                <a:latin typeface="Plus Jakarta Sans"/>
-              </a:rPr>
-              <a:t>■  </a:t>
-            </a:r>
-            <a:r>
-              <a:rPr sz="1500" b="1">
-                <a:solidFill>
-                  <a:srgbClr val="171A18"/>
-                </a:solidFill>
-                <a:latin typeface="Plus Jakarta Sans"/>
-              </a:rPr>
-              <a:t>Completely Private &amp; Local:
-</a:t>
-            </a:r>
-            <a:r>
-              <a:rPr sz="1400">
-                <a:solidFill>
-                  <a:srgbClr val="526058"/>
-                </a:solidFill>
-                <a:latin typeface="Plus Jakarta Sans"/>
-              </a:rPr>
-              <a:t>   Install from ollama.com. Runs entirely on your laptop hardware without needing an internet connection.</a:t>
-            </a:r>
-          </a:p>
-          <a:p>
-            <a:pPr>
-              <a:spcBef>
-                <a:spcPts val="1400"/>
-              </a:spcBef>
-            </a:pPr>
-            <a:r>
-              <a:rPr sz="1000">
-                <a:solidFill>
-                  <a:srgbClr val="1F6B4F"/>
-                </a:solidFill>
-                <a:latin typeface="Plus Jakarta Sans"/>
-              </a:rPr>
-              <a:t>■  </a:t>
-            </a:r>
-            <a:r>
-              <a:rPr sz="1500" b="1">
-                <a:solidFill>
-                  <a:srgbClr val="171A18"/>
-                </a:solidFill>
-                <a:latin typeface="Plus Jakarta Sans"/>
-              </a:rPr>
-              <a:t>Recommended Model:
-</a:t>
-            </a:r>
-            <a:r>
-              <a:rPr sz="1400">
-                <a:solidFill>
-                  <a:srgbClr val="526058"/>
-                </a:solidFill>
-                <a:latin typeface="Plus Jakarta Sans"/>
-              </a:rPr>
-              <a:t>   qwen2.5-coder:7b delivers outstanding coding logic on standard laptops with 8GB to 16GB of RAM.</a:t>
-            </a:r>
-          </a:p>
-          <a:p>
-            <a:pPr>
-              <a:spcBef>
-                <a:spcPts val="1400"/>
-              </a:spcBef>
-            </a:pPr>
-            <a:r>
-              <a:rPr sz="1000">
-                <a:solidFill>
-                  <a:srgbClr val="1F6B4F"/>
-                </a:solidFill>
-                <a:latin typeface="Plus Jakarta Sans"/>
-              </a:rPr>
-              <a:t>■  </a:t>
-            </a:r>
-            <a:r>
-              <a:rPr sz="1500" b="1">
-                <a:solidFill>
-                  <a:srgbClr val="171A18"/>
-                </a:solidFill>
-                <a:latin typeface="Plus Jakarta Sans"/>
-              </a:rPr>
-              <a:t>Zero Latency:
-</a:t>
-            </a:r>
-            <a:r>
-              <a:rPr sz="1400">
-                <a:solidFill>
-                  <a:srgbClr val="526058"/>
-                </a:solidFill>
-                <a:latin typeface="Plus Jakarta Sans"/>
-              </a:rPr>
-              <a:t>   Instant responses directly on device with zero dependence on external network connectivity.</a:t>
-            </a:r>
-          </a:p>
-        </p:txBody>
-      </p:sp>
-    </p:spTree>
-  </p:cSld>
-  <p:clrMapOvr>
-    <a:masterClrMapping/>
-  </p:clrMapOvr>
-</p:sld>
-</file>
-
-<file path=ppt/slides/slide14.xml><?xml version="1.0" encoding="utf-8"?>
-<p:sld xmlns:a="http://schemas.openxmlformats.org/drawingml/2006/main" xmlns:p="http://schemas.openxmlformats.org/presentationml/2006/main" xmlns:r="http://schemas.openxmlformats.org/officeDocument/2006/relationships">
-  <p:cSld>
-    <p:spTree>
-      <p:nvGrpSpPr>
-        <p:cNvPr id="1" name=""/>
-        <p:cNvGrpSpPr/>
-        <p:nvPr/>
-      </p:nvGrpSpPr>
-      <p:grpSpPr/>
-      <p:sp>
-        <p:nvSpPr>
-          <p:cNvPr id="2" name="TextBox 1"/>
-          <p:cNvSpPr txBox="1"/>
-          <p:nvPr/>
-        </p:nvSpPr>
-        <p:spPr>
-          <a:xfrm>
-            <a:off x="1371600" y="731520"/>
-            <a:ext cx="9418320" cy="822960"/>
-          </a:xfrm>
-          <a:prstGeom prst="rect">
-            <a:avLst/>
-          </a:prstGeom>
-          <a:noFill/>
-        </p:spPr>
-        <p:txBody>
-          <a:bodyPr wrap="square">
-            <a:spAutoFit/>
-          </a:bodyPr>
-          <a:lstStyle/>
-          <a:p>
-            <a:pPr algn="ctr">
-              <a:defRPr sz="3200" b="1">
-                <a:solidFill>
-                  <a:srgbClr val="171A18"/>
-                </a:solidFill>
-                <a:latin typeface="Plus Jakarta Sans"/>
-              </a:defRPr>
-            </a:pPr>
-            <a:r>
-              <a:t>Reality Check: The Compiler Never Lies</a:t>
-            </a:r>
-          </a:p>
-        </p:txBody>
-      </p:sp>
-      <p:sp>
-        <p:nvSpPr>
-          <p:cNvPr id="3" name="Rectangle 2"/>
-          <p:cNvSpPr/>
-          <p:nvPr/>
-        </p:nvSpPr>
-        <p:spPr>
-          <a:xfrm>
-            <a:off x="2560320" y="1645920"/>
-            <a:ext cx="7040880" cy="3931920"/>
-          </a:xfrm>
-          <a:prstGeom prst="rect">
-            <a:avLst/>
-          </a:prstGeom>
-          <a:solidFill>
-            <a:srgbClr val="F8FAF8"/>
-          </a:solidFill>
-          <a:ln w="19050">
-            <a:solidFill>
-              <a:srgbClr val="1F6B4F"/>
-            </a:solidFill>
-          </a:ln>
-        </p:spPr>
-        <p:style>
-          <a:lnRef idx="1">
-            <a:schemeClr val="accent1"/>
-          </a:lnRef>
-          <a:fillRef idx="3">
-            <a:schemeClr val="accent1"/>
-          </a:fillRef>
-          <a:effectRef idx="2">
-            <a:schemeClr val="accent1"/>
-          </a:effectRef>
-          <a:fontRef idx="minor">
-            <a:schemeClr val="lt1"/>
-          </a:fontRef>
-        </p:style>
-        <p:txBody>
-          <a:bodyPr rtlCol="0" anchor="ctr" wrap="square"/>
-          <a:lstStyle/>
-          <a:p>
-            <a:pPr algn="ctr">
-              <a:defRPr sz="1800" b="1">
-                <a:solidFill>
-                  <a:srgbClr val="1F6B4F"/>
-                </a:solidFill>
-                <a:latin typeface="Plus Jakarta Sans"/>
-              </a:defRPr>
-            </a:pPr>
-            <a:r>
-              <a:t>[MEME 04 PLACEHOLDER: AI claims bugs are fixed vs Compiler errors]</a:t>
-            </a:r>
-          </a:p>
-          <a:p>
-            <a:pPr algn="ctr">
-              <a:spcBef>
-                <a:spcPts val="800"/>
-              </a:spcBef>
-              <a:defRPr sz="1300">
-                <a:solidFill>
-                  <a:srgbClr val="526058"/>
-                </a:solidFill>
-                <a:latin typeface="Plus Jakarta Sans"/>
-              </a:defRPr>
-            </a:pPr>
-            <a:r>
-              <a:t>(Drop your meme image here or delete this box)</a:t>
-            </a:r>
-          </a:p>
-        </p:txBody>
-      </p:sp>
-      <p:sp>
-        <p:nvSpPr>
-          <p:cNvPr id="4" name="TextBox 3"/>
-          <p:cNvSpPr txBox="1"/>
-          <p:nvPr/>
-        </p:nvSpPr>
-        <p:spPr>
-          <a:xfrm>
-            <a:off x="2286000" y="5760720"/>
-            <a:ext cx="7589520" cy="731520"/>
-          </a:xfrm>
-          <a:prstGeom prst="rect">
-            <a:avLst/>
-          </a:prstGeom>
-          <a:noFill/>
-        </p:spPr>
-        <p:txBody>
-          <a:bodyPr wrap="square">
-            <a:spAutoFit/>
-          </a:bodyPr>
-          <a:lstStyle/>
-          <a:p>
-            <a:pPr algn="ctr">
-              <a:defRPr sz="1500">
-                <a:solidFill>
-                  <a:srgbClr val="526058"/>
-                </a:solidFill>
-                <a:latin typeface="Plus Jakarta Sans"/>
-              </a:defRPr>
-            </a:pPr>
-            <a:r>
-              <a:t>"I fixed all the bugs," says the AI model. The compiler: 47 errors found in 3 files.</a:t>
+              <a:t>Prompting is only 20% of the work. Testing whether the buttons actually work is the other 80%.</a:t>
             </a:r>
           </a:p>
         </p:txBody>
@@ -4815,7 +4892,7 @@
               </a:defRPr>
             </a:pPr>
             <a:r>
-              <a:t>The Linear Packaging Problem</a:t>
+              <a:t>The Packaging Trap: Multi-Layer Plastics</a:t>
             </a:r>
           </a:p>
           <a:p>
@@ -4831,7 +4908,7 @@
               </a:defRPr>
             </a:pPr>
             <a:r>
-              <a:t>Why conventional municipal recycling fails on modern multi-layer packaging.</a:t>
+              <a:t>Why standard municipal recyclers throw clean packaging straight into landfills.</a:t>
             </a:r>
           </a:p>
         </p:txBody>
@@ -4892,7 +4969,7 @@
                 </a:solidFill>
                 <a:latin typeface="Plus Jakarta Sans"/>
               </a:rPr>
-              <a:t>Multi-Layer Packaging (MLP):
+              <a:t>Bonded Metal &amp; Plastic:
 </a:t>
             </a:r>
             <a:r>
@@ -4902,7 +4979,7 @@
                 </a:solidFill>
                 <a:latin typeface="Plus Jakarta Sans"/>
               </a:rPr>
-              <a:t>   Chips and snack packaging fuse plastic films with aluminum foil. Standard recyclers cannot separate these layers cost-effectively, diverting millions of tons directly to landfills.</a:t>
+              <a:t>   Chips and snack packets laminate aluminum foil between plastic film. Separating those layers is chemically difficult and commercially unprofitable.</a:t>
             </a:r>
           </a:p>
           <a:p>
@@ -4927,7 +5004,7 @@
                 </a:solidFill>
                 <a:latin typeface="Plus Jakarta Sans"/>
               </a:rPr>
-              <a:t>Fragmented Logistics:
+              <a:t>100% Landfill Destination:
 </a:t>
             </a:r>
             <a:r>
@@ -4937,7 +5014,7 @@
                 </a:solidFill>
                 <a:latin typeface="Plus Jakarta Sans"/>
               </a:rPr>
-              <a:t>   Communities and schools generate clean packaging waste, but lack direct channels connecting them to verified upcycling alternatives.</a:t>
+              <a:t>   Because municipal plants cannot process multi-layer packaging, almost all snack wrappers are burned or dumped into local landfills.</a:t>
             </a:r>
           </a:p>
           <a:p>
@@ -4962,7 +5039,7 @@
                 </a:solidFill>
                 <a:latin typeface="Plus Jakarta Sans"/>
               </a:rPr>
-              <a:t>Information Asymmetry:
+              <a:t>Clean Waste in Schools:
 </a:t>
             </a:r>
             <a:r>
@@ -4972,7 +5049,7 @@
                 </a:solidFill>
                 <a:latin typeface="Plus Jakarta Sans"/>
               </a:rPr>
-              <a:t>   Consumers and institutions cannot verify whether their sorted recyclables are actually reprocessed or simply dumped.</a:t>
+              <a:t>   Canteens and classrooms generate sacks of clean snack wrappers daily with zero realistic collection logistics.</a:t>
             </a:r>
           </a:p>
         </p:txBody>
@@ -5033,7 +5110,7 @@
                 </a:solidFill>
                 <a:latin typeface="Plus Jakarta Sans"/>
               </a:rPr>
-              <a:t>Mechanical Upcycling:
+              <a:t>Skip Separation, Heat-Compress:
 </a:t>
             </a:r>
             <a:r>
@@ -5043,7 +5120,7 @@
                 </a:solidFill>
                 <a:latin typeface="Plus Jakarta Sans"/>
               </a:rPr>
-              <a:t>   Heat-compressing clean multi-layer plastics into structural sheets that replace traditional plywood and particle boards.</a:t>
+              <a:t>   Instead of separating the foil, we partner to heat-press whole wrappers into dense boards that replace plywood.</a:t>
             </a:r>
           </a:p>
           <a:p>
@@ -5068,7 +5145,7 @@
                 </a:solidFill>
                 <a:latin typeface="Plus Jakarta Sans"/>
               </a:rPr>
-              <a:t>Digital Transparency:
+              <a:t>Unified Circular Model:
 </a:t>
             </a:r>
             <a:r>
@@ -5078,7 +5155,7 @@
                 </a:solidFill>
                 <a:latin typeface="Plus Jakarta Sans"/>
               </a:rPr>
-              <a:t>   Publishing exact material specifications, density metrics, and inventory through an open platform.</a:t>
+              <a:t>   Unifying scattered school green crafts and outsourced heavy materials into one clean system.</a:t>
             </a:r>
           </a:p>
           <a:p>
@@ -5103,7 +5180,7 @@
                 </a:solidFill>
                 <a:latin typeface="Plus Jakarta Sans"/>
               </a:rPr>
-              <a:t>Closed Institutional Loops:
+              <a:t>Digital Transparency:
 </a:t>
             </a:r>
             <a:r>
@@ -5113,7 +5190,7 @@
                 </a:solidFill>
                 <a:latin typeface="Plus Jakarta Sans"/>
               </a:rPr>
-              <a:t>   Partnering directly with campuses to collect, process, and return finished utility goods back to the source.</a:t>
+              <a:t>   Building an online catalog so buyers can see exact specifications and request real samples.</a:t>
             </a:r>
           </a:p>
         </p:txBody>
@@ -5167,7 +5244,7 @@
               </a:defRPr>
             </a:pPr>
             <a:r>
-              <a:t>The Physical Loop: Verified Materials</a:t>
+              <a:t>The Physical Loop: In-House Crafts &amp; NGO Partnership</a:t>
             </a:r>
           </a:p>
           <a:p>
@@ -5183,7 +5260,7 @@
               </a:defRPr>
             </a:pPr>
             <a:r>
-              <a:t>Six circular products systematically diverted from waste streams.</a:t>
+              <a:t>What we make directly in school, and what we produce with our partner NGO.</a:t>
             </a:r>
           </a:p>
         </p:txBody>
@@ -5211,13 +5288,13 @@
           <a:lstStyle/>
           <a:p>
             <a:r>
-              <a:rPr sz="1500" b="1">
+              <a:rPr sz="1450" b="1">
                 <a:solidFill>
                   <a:srgbClr val="1F6B4F"/>
                 </a:solidFill>
                 <a:latin typeface="Plus Jakarta Sans"/>
               </a:rPr>
-              <a:t>■  Eco-Bricks
+              <a:t>■  Student-Made: Seed Paper
 </a:t>
             </a:r>
             <a:r>
@@ -5227,23 +5304,23 @@
                 </a:solidFill>
                 <a:latin typeface="Plus Jakarta Sans"/>
               </a:rPr>
-              <a:t>   High-density PET containers packed with clean flexible plastics.</a:t>
+              <a:t>   Handmade plantable paper embedded with native seeds, crafted in school.</a:t>
             </a:r>
           </a:p>
           <a:p>
             <a:pPr>
               <a:spcBef>
-                <a:spcPts val="1200"/>
+                <a:spcPts val="1100"/>
               </a:spcBef>
             </a:pPr>
             <a:r>
-              <a:rPr sz="1500" b="1">
+              <a:rPr sz="1450" b="1">
                 <a:solidFill>
                   <a:srgbClr val="1F6B4F"/>
                 </a:solidFill>
                 <a:latin typeface="Plus Jakarta Sans"/>
               </a:rPr>
-              <a:t>■  MLP Sheets
+              <a:t>■  Student-Made: Bioenzymes
 </a:t>
             </a:r>
             <a:r>
@@ -5253,23 +5330,23 @@
                 </a:solidFill>
                 <a:latin typeface="Plus Jakarta Sans"/>
               </a:rPr>
-              <a:t>   Heat-pressed multi-layer packaging replacing standard plywood.</a:t>
+              <a:t>   Citrus fruit peels fermented into natural multi-purpose cleaning liquids.</a:t>
             </a:r>
           </a:p>
           <a:p>
             <a:pPr>
               <a:spcBef>
-                <a:spcPts val="1200"/>
+                <a:spcPts val="1100"/>
               </a:spcBef>
             </a:pPr>
             <a:r>
-              <a:rPr sz="1500" b="1">
+              <a:rPr sz="1450" b="1">
                 <a:solidFill>
                   <a:srgbClr val="1F6B4F"/>
                 </a:solidFill>
                 <a:latin typeface="Plus Jakarta Sans"/>
               </a:rPr>
-              <a:t>■  Bottle Planters
+              <a:t>■  Student-Made: Uniform Bags
 </a:t>
             </a:r>
             <a:r>
@@ -5279,23 +5356,23 @@
                 </a:solidFill>
                 <a:latin typeface="Plus Jakarta Sans"/>
               </a:rPr>
-              <a:t>   Upcycled PET containers for nursery and hydroponic gardening.</a:t>
+              <a:t>   Durable tote bags stitched from discarded school uniform fabrics.</a:t>
             </a:r>
           </a:p>
           <a:p>
             <a:pPr>
               <a:spcBef>
-                <a:spcPts val="1200"/>
+                <a:spcPts val="1100"/>
               </a:spcBef>
             </a:pPr>
             <a:r>
-              <a:rPr sz="1500" b="1">
+              <a:rPr sz="1450" b="1">
                 <a:solidFill>
                   <a:srgbClr val="1F6B4F"/>
                 </a:solidFill>
                 <a:latin typeface="Plus Jakarta Sans"/>
               </a:rPr>
-              <a:t>■  Uniform Bags
+              <a:t>■  Student-Made: Eco-Bricks
 </a:t>
             </a:r>
             <a:r>
@@ -5305,23 +5382,23 @@
                 </a:solidFill>
                 <a:latin typeface="Plus Jakarta Sans"/>
               </a:rPr>
-              <a:t>   Heavyweight tote bags repurposed from discarded school uniforms.</a:t>
+              <a:t>   PET bottles tightly packed with clean plastic wrappers for simple construction.</a:t>
             </a:r>
           </a:p>
           <a:p>
             <a:pPr>
               <a:spcBef>
-                <a:spcPts val="1200"/>
+                <a:spcPts val="1100"/>
               </a:spcBef>
             </a:pPr>
             <a:r>
-              <a:rPr sz="1500" b="1">
+              <a:rPr sz="1450" b="1">
                 <a:solidFill>
                   <a:srgbClr val="1F6B4F"/>
                 </a:solidFill>
                 <a:latin typeface="Plus Jakarta Sans"/>
               </a:rPr>
-              <a:t>■  Seed Paper
+              <a:t>■  Student-Made: Bottle Planters
 </a:t>
             </a:r>
             <a:r>
@@ -5331,23 +5408,23 @@
                 </a:solidFill>
                 <a:latin typeface="Plus Jakarta Sans"/>
               </a:rPr>
-              <a:t>   Zero-bleach handmade paper embedded with native plant seeds.</a:t>
+              <a:t>   Upcycled beverage containers for school corridor nursery gardening.</a:t>
             </a:r>
           </a:p>
           <a:p>
             <a:pPr>
               <a:spcBef>
-                <a:spcPts val="1200"/>
+                <a:spcPts val="1100"/>
               </a:spcBef>
             </a:pPr>
             <a:r>
-              <a:rPr sz="1500" b="1">
-                <a:solidFill>
-                  <a:srgbClr val="1F6B4F"/>
-                </a:solidFill>
-                <a:latin typeface="Plus Jakarta Sans"/>
-              </a:rPr>
-              <a:t>■  Bioenzymes
+              <a:rPr sz="1450" b="1">
+                <a:solidFill>
+                  <a:srgbClr val="288563"/>
+                </a:solidFill>
+                <a:latin typeface="Plus Jakarta Sans"/>
+              </a:rPr>
+              <a:t>■  NGO Partnership: MLP Sheets
 </a:t>
             </a:r>
             <a:r>
@@ -5357,7 +5434,7 @@
                 </a:solidFill>
                 <a:latin typeface="Plus Jakarta Sans"/>
               </a:rPr>
-              <a:t>   Citrus-fermented organic cleaning concentrates.</a:t>
+              <a:t>   Heavy-duty boards heat-pressed from snack wrappers using hydraulic machinery.</a:t>
             </a:r>
           </a:p>
         </p:txBody>
@@ -5490,7 +5567,7 @@
               </a:defRPr>
             </a:pPr>
             <a:r>
-              <a:t>[MEME 01 PLACEHOLDER: How It Started vs How It Is Going]</a:t>
+              <a:t>[MEME 01: Teachers thinking we'd just pick up litter vs Building a brand &amp; platform]</a:t>
             </a:r>
           </a:p>
           <a:p>
@@ -5542,7 +5619,7 @@
               </a:defRPr>
             </a:pPr>
             <a:r>
-              <a:t>Started by collecting empty snack wrappers in school. Ended up building an automated cloud software platform.</a:t>
+              <a:t>Started as scattered classroom craft projects. Turned into a unified circular brand with external partnerships and custom software.</a:t>
             </a:r>
           </a:p>
         </p:txBody>
@@ -5596,7 +5673,7 @@
               </a:defRPr>
             </a:pPr>
             <a:r>
-              <a:t>Why Physical Projects Need Software</a:t>
+              <a:t>Why Build a Digital Platform?</a:t>
             </a:r>
           </a:p>
           <a:p>
@@ -5612,7 +5689,7 @@
               </a:defRPr>
             </a:pPr>
             <a:r>
-              <a:t>Moving from static school displays to an open, operational platform.</a:t>
+              <a:t>Transforming school crafts into verifiable, specification-backed utility products.</a:t>
             </a:r>
           </a:p>
         </p:txBody>
@@ -5648,7 +5725,7 @@
               </a:defRPr>
             </a:pPr>
             <a:r>
-              <a:t>Platform Capabilities</a:t>
+              <a:t>Platform Objectives</a:t>
             </a:r>
           </a:p>
           <a:p>
@@ -5673,7 +5750,7 @@
                 </a:solidFill>
                 <a:latin typeface="Plus Jakarta Sans"/>
               </a:rPr>
-              <a:t>Engineering Specifications:
+              <a:t>Engineering Credibility:
 </a:t>
             </a:r>
             <a:r>
@@ -5683,7 +5760,7 @@
                 </a:solidFill>
                 <a:latin typeface="Plus Jakarta Sans"/>
               </a:rPr>
-              <a:t>   Every product includes physical dimensions, density metrics, thermal characteristics, and production lead times.</a:t>
+              <a:t>   Publishing actual dimensions, material density, thermal ratings, and production lead times so buyers take recycled goods seriously.</a:t>
             </a:r>
           </a:p>
           <a:p>
@@ -5708,7 +5785,7 @@
                 </a:solidFill>
                 <a:latin typeface="Plus Jakarta Sans"/>
               </a:rPr>
-              <a:t>Direct Transaction Routing:
+              <a:t>Direct Inquiry Routing:
 </a:t>
             </a:r>
             <a:r>
@@ -5718,7 +5795,7 @@
                 </a:solidFill>
                 <a:latin typeface="Plus Jakarta Sans"/>
               </a:rPr>
-              <a:t>   Schools and community partners can query stock, request material samples, and submit institutional orders.</a:t>
+              <a:t>   Giving institutions and partners a friction-free way to query available stock and request physical samples.</a:t>
             </a:r>
           </a:p>
           <a:p>
@@ -5743,7 +5820,7 @@
                 </a:solidFill>
                 <a:latin typeface="Plus Jakarta Sans"/>
               </a:rPr>
-              <a:t>Modern Frontend Stack:
+              <a:t>Connecting School to Outside World:
 </a:t>
             </a:r>
             <a:r>
@@ -5753,7 +5830,7 @@
                 </a:solidFill>
                 <a:latin typeface="Plus Jakarta Sans"/>
               </a:rPr>
-              <a:t>   React 18 with TypeScript and Vite for fast client-side navigation and strict type safety.</a:t>
+              <a:t>   Taking activities happening inside classrooms and presenting them professionally to external organizations.</a:t>
             </a:r>
           </a:p>
         </p:txBody>
@@ -5831,7 +5908,7 @@
               </a:defRPr>
             </a:pPr>
             <a:r>
-              <a:t>The Zero-Cost Serverless Backend</a:t>
+              <a:t>The Zero-Cost Backend: Built on Google Sheets</a:t>
             </a:r>
           </a:p>
           <a:p>
@@ -5847,7 +5924,7 @@
               </a:defRPr>
             </a:pPr>
             <a:r>
-              <a:t>Delivering full transactional workflows without servers or ongoing bills.</a:t>
+              <a:t>Handling live incoming inquiries without paid servers or corporate credit cards.</a:t>
             </a:r>
           </a:p>
         </p:txBody>
@@ -5918,7 +5995,7 @@
               </a:defRPr>
             </a:pPr>
             <a:r>
-              <a:t>React Client</a:t>
+              <a:t>React Form</a:t>
             </a:r>
           </a:p>
           <a:p>
@@ -5934,7 +6011,7 @@
               </a:defRPr>
             </a:pPr>
             <a:r>
-              <a:t>User submits an inquiry; client-side validation ensures clean data before transmission.</a:t>
+              <a:t>User fills in their name, product choice, and notes. The browser validates all inputs locally.</a:t>
             </a:r>
           </a:p>
         </p:txBody>
@@ -6021,7 +6098,7 @@
               </a:defRPr>
             </a:pPr>
             <a:r>
-              <a:t>A stateless Google Apps Script endpoint receives and parses JSON payload securely.</a:t>
+              <a:t>A free Google Apps Script webhook receives the data payload securely in the cloud.</a:t>
             </a:r>
           </a:p>
         </p:txBody>
@@ -6092,7 +6169,7 @@
               </a:defRPr>
             </a:pPr>
             <a:r>
-              <a:t>Sheets Datastore</a:t>
+              <a:t>Sheets Database</a:t>
             </a:r>
           </a:p>
           <a:p>
@@ -6108,7 +6185,7 @@
               </a:defRPr>
             </a:pPr>
             <a:r>
-              <a:t>Appends records, updates inventory tracking, and triggers automated email alerts.</a:t>
+              <a:t>Appends the inquiry row into a live Google Sheet and immediately triggers an email alert.</a:t>
             </a:r>
           </a:p>
         </p:txBody>
@@ -6162,7 +6239,7 @@
                 </a:solidFill>
                 <a:latin typeface="Plus Jakarta Sans"/>
               </a:rPr>
-              <a:t>Total Infrastructure Operating Cost:   </a:t>
+              <a:t>Monthly Infrastructure Bill:   </a:t>
             </a:r>
             <a:r>
               <a:rPr sz="2400" b="1">
@@ -6181,7 +6258,7 @@
                 </a:solidFill>
                 <a:latin typeface="Plus Jakarta Sans"/>
               </a:rPr>
-              <a:t>No credit card required. Zero servers to maintain. 99.9% uptime.</a:t>
+              <a:t>No credit cards, zero server maintenance, and reliable for real order leads.</a:t>
             </a:r>
           </a:p>
         </p:txBody>
@@ -6290,7 +6367,7 @@
               </a:defRPr>
             </a:pPr>
             <a:r>
-              <a:t>[MEME 02 PLACEHOLDER: $450/mo AWS vs $0 Google Sheets]</a:t>
+              <a:t>[MEME 02: Paying $50/month for cloud databases vs High schoolers using a free Google Sheet]</a:t>
             </a:r>
           </a:p>
           <a:p>
@@ -6342,7 +6419,7 @@
               </a:defRPr>
             </a:pPr>
             <a:r>
-              <a:t>Enterprise developers arguing about Kubernetes microservices while two high schoolers run production on Google Sheets.</a:t>
+              <a:t>Why spend monthly money on complex database servers when a free Google Sheet captures all your orders?</a:t>
             </a:r>
           </a:p>
         </p:txBody>
@@ -6396,7 +6473,7 @@
               </a:defRPr>
             </a:pPr>
             <a:r>
-              <a:t>Interactive Inquiry Engine</a:t>
+              <a:t>The Inquiry Engine: An Honest Review</a:t>
             </a:r>
           </a:p>
           <a:p>
@@ -6412,7 +6489,7 @@
               </a:defRPr>
             </a:pPr>
             <a:r>
-              <a:t>Handling institutional orders and sample requests with context preservation.</a:t>
+              <a:t>Built in a single night sprint: functional, basic, and with plenty of room to improve.</a:t>
             </a:r>
           </a:p>
         </p:txBody>
@@ -6448,7 +6525,7 @@
               </a:defRPr>
             </a:pPr>
             <a:r>
-              <a:t>Order &amp; Sample Workflow</a:t>
+              <a:t>The Reality of Our MVP</a:t>
             </a:r>
           </a:p>
           <a:p>
@@ -6473,7 +6550,7 @@
                 </a:solidFill>
                 <a:latin typeface="Plus Jakarta Sans"/>
               </a:rPr>
-              <a:t>Contextual Pre-Filling:
+              <a:t>Built in One Night:
 </a:t>
             </a:r>
             <a:r>
@@ -6483,7 +6560,7 @@
                 </a:solidFill>
                 <a:latin typeface="Plus Jakarta Sans"/>
               </a:rPr>
-              <a:t>   Selecting an item automatically binds its product ID, specifications, and suggested order minimums into form state.</a:t>
+              <a:t>   Put together in a single late-night sprint to give the CBSE exhibition judges a working demo to test.</a:t>
             </a:r>
           </a:p>
           <a:p>
@@ -6508,7 +6585,7 @@
                 </a:solidFill>
                 <a:latin typeface="Plus Jakarta Sans"/>
               </a:rPr>
-              <a:t>Client-Side Validation:
+              <a:t>Basic but Working:
 </a:t>
             </a:r>
             <a:r>
@@ -6518,7 +6595,7 @@
                 </a:solidFill>
                 <a:latin typeface="Plus Jakarta Sans"/>
               </a:rPr>
-              <a:t>   Immediate feedback flags incomplete or invalid entries before triggering network dispatches.</a:t>
+              <a:t>   Automatically pre-populates product details and logs records straight into our backend without paying for services.</a:t>
             </a:r>
           </a:p>
           <a:p>
@@ -6543,7 +6620,7 @@
                 </a:solidFill>
                 <a:latin typeface="Plus Jakarta Sans"/>
               </a:rPr>
-              <a:t>Confirmation &amp; Logging:
+              <a:t>Room for Improvement:
 </a:t>
             </a:r>
             <a:r>
@@ -6553,7 +6630,7 @@
                 </a:solidFill>
                 <a:latin typeface="Plus Jakarta Sans"/>
               </a:rPr>
-              <a:t>   A clean confirmation modal displays expected turnaround times while logging data directly to the spreadsheet.</a:t>
+              <a:t>   Needs automated inventory deduction, better error states, and order tracking. It's an MVP, not final software.</a:t>
             </a:r>
           </a:p>
         </p:txBody>
@@ -6631,7 +6708,7 @@
               </a:defRPr>
             </a:pPr>
             <a:r>
-              <a:t>The Paradigm Shift: Developer as Architect</a:t>
+              <a:t>How I Built It Without Knowing React</a:t>
             </a:r>
           </a:p>
           <a:p>
@@ -6647,7 +6724,7 @@
               </a:defRPr>
             </a:pPr>
             <a:r>
-              <a:t>How autonomous workflows shift focus from repetitive syntax to system design.</a:t>
+              <a:t>Moving from typing boilerplate code to designing systems with AI agents.</a:t>
             </a:r>
           </a:p>
         </p:txBody>
@@ -6683,7 +6760,7 @@
               </a:defRPr>
             </a:pPr>
             <a:r>
-              <a:t>Traditional Coding</a:t>
+              <a:t>The Traditional Hurdle</a:t>
             </a:r>
           </a:p>
           <a:p>
@@ -6708,7 +6785,7 @@
                 </a:solidFill>
                 <a:latin typeface="Plus Jakarta Sans"/>
               </a:rPr>
-              <a:t>Manual Syntax Typing:
+              <a:t>Syntax Friction:
 </a:t>
             </a:r>
             <a:r>
@@ -6718,7 +6795,7 @@
                 </a:solidFill>
                 <a:latin typeface="Plus Jakarta Sans"/>
               </a:rPr>
-              <a:t>   Manually typing repetitive component boilerplate and state handlers line by line.</a:t>
+              <a:t>   Getting stuck on missing brackets, package version mismatches, and unfamiliar framework setup.</a:t>
             </a:r>
           </a:p>
           <a:p>
@@ -6743,7 +6820,7 @@
                 </a:solidFill>
                 <a:latin typeface="Plus Jakarta Sans"/>
               </a:rPr>
-              <a:t>Dependency Friction:
+              <a:t>Hours on Forums:
 </a:t>
             </a:r>
             <a:r>
@@ -6753,7 +6830,7 @@
                 </a:solidFill>
                 <a:latin typeface="Plus Jakarta Sans"/>
               </a:rPr>
-              <a:t>   Spending hours searching forum threads to diagnose broken npm packages and imports.</a:t>
+              <a:t>   Spending entire evenings digging through Stack Overflow threads instead of building real features.</a:t>
             </a:r>
           </a:p>
           <a:p>
@@ -6778,7 +6855,7 @@
                 </a:solidFill>
                 <a:latin typeface="Plus Jakarta Sans"/>
               </a:rPr>
-              <a:t>Low-Level Bugs:
+              <a:t>Idea Blocked:
 </a:t>
             </a:r>
             <a:r>
@@ -6788,7 +6865,7 @@
                 </a:solidFill>
                 <a:latin typeface="Plus Jakarta Sans"/>
               </a:rPr>
-              <a:t>   Getting stuck on typos and syntax bugs instead of building real user features.</a:t>
+              <a:t>   Giving up on software ideas simply because you haven't spent 6 months memorizing syntax.</a:t>
             </a:r>
           </a:p>
         </p:txBody>
@@ -6824,7 +6901,7 @@
               </a:defRPr>
             </a:pPr>
             <a:r>
-              <a:t>Autonomous AI Coding</a:t>
+              <a:t>Developer as Architect</a:t>
             </a:r>
           </a:p>
           <a:p>
@@ -6849,7 +6926,7 @@
                 </a:solidFill>
                 <a:latin typeface="Plus Jakarta Sans"/>
               </a:rPr>
-              <a:t>Define System Constraints:
+              <a:t>Define the System Rules:
 </a:t>
             </a:r>
             <a:r>
@@ -6859,7 +6936,7 @@
                 </a:solidFill>
                 <a:latin typeface="Plus Jakarta Sans"/>
               </a:rPr>
-              <a:t>   You define the core goals, system constraints, component contracts, and visual design rules.</a:t>
+              <a:t>   You specify the data models, visual style, and constraints in plain language.</a:t>
             </a:r>
           </a:p>
           <a:p>
@@ -6884,7 +6961,7 @@
                 </a:solidFill>
                 <a:latin typeface="Plus Jakarta Sans"/>
               </a:rPr>
-              <a:t>Autonomous Agent Edits:
+              <a:t>Agents Write the Code:
 </a:t>
             </a:r>
             <a:r>
@@ -6894,7 +6971,7 @@
                 </a:solidFill>
                 <a:latin typeface="Plus Jakarta Sans"/>
               </a:rPr>
-              <a:t>   The AI agent explores your files, writes components, and links routes across the codebase.</a:t>
+              <a:t>   An autonomous agent creates components, connects routes, and modifies multiple files.</a:t>
             </a:r>
           </a:p>
           <a:p>
@@ -6919,7 +6996,7 @@
                 </a:solidFill>
                 <a:latin typeface="Plus Jakarta Sans"/>
               </a:rPr>
-              <a:t>Automated Verification:
+              <a:t>Focus on Testing:
 </a:t>
             </a:r>
             <a:r>
@@ -6929,7 +7006,7 @@
                 </a:solidFill>
                 <a:latin typeface="Plus Jakarta Sans"/>
               </a:rPr>
-              <a:t>   Automated tools test the code, surface errors, and repair bugs instantly.</a:t>
+              <a:t>   Your primary job becomes quality control, testing user flows, and refining the architecture.</a:t>
             </a:r>
           </a:p>
         </p:txBody>

</xml_diff>

<commit_message>
update slide 3 physical loop, bro think he recyclable placeholder, and live cropped homepage
</commit_message>
<xml_diff>
--- a/docs/presentation/ecoloop-presentation.pptx
+++ b/docs/presentation/ecoloop-presentation.pptx
@@ -5244,7 +5244,7 @@
               </a:defRPr>
             </a:pPr>
             <a:r>
-              <a:t>The Physical Loop: In-House Crafts &amp; NGO Partnership</a:t>
+              <a:t>The Physical Loop</a:t>
             </a:r>
           </a:p>
           <a:p>
@@ -5260,7 +5260,7 @@
               </a:defRPr>
             </a:pPr>
             <a:r>
-              <a:t>What we make directly in school, and what we produce with our partner NGO.</a:t>
+              <a:t>Six circular products systematically diverted from waste streams.</a:t>
             </a:r>
           </a:p>
         </p:txBody>
@@ -5439,20 +5439,12 @@
           </a:p>
         </p:txBody>
       </p:sp>
-      <p:pic>
-        <p:nvPicPr>
-          <p:cNvPr id="4" name="Picture 3" descr="sample-mlp.jpg"/>
-          <p:cNvPicPr>
-            <a:picLocks noChangeAspect="1"/>
-          </p:cNvPicPr>
+      <p:sp>
+        <p:nvSpPr>
+          <p:cNvPr id="4" name="Rectangle 3"/>
+          <p:cNvSpPr/>
           <p:nvPr/>
-        </p:nvPicPr>
-        <p:blipFill>
-          <a:blip r:embed="rId2"/>
-          <a:stretch>
-            <a:fillRect/>
-          </a:stretch>
-        </p:blipFill>
+        </p:nvSpPr>
         <p:spPr>
           <a:xfrm>
             <a:off x="6309360" y="2011680"/>
@@ -5461,8 +5453,68 @@
           <a:prstGeom prst="rect">
             <a:avLst/>
           </a:prstGeom>
+          <a:solidFill>
+            <a:srgbClr val="F0F6F2"/>
+          </a:solidFill>
+          <a:ln w="19050">
+            <a:solidFill>
+              <a:srgbClr val="1F6B4F"/>
+            </a:solidFill>
+          </a:ln>
         </p:spPr>
-      </p:pic>
+        <p:style>
+          <a:lnRef idx="1">
+            <a:schemeClr val="accent1"/>
+          </a:lnRef>
+          <a:fillRef idx="3">
+            <a:schemeClr val="accent1"/>
+          </a:fillRef>
+          <a:effectRef idx="2">
+            <a:schemeClr val="accent1"/>
+          </a:effectRef>
+          <a:fontRef idx="minor">
+            <a:schemeClr val="lt1"/>
+          </a:fontRef>
+        </p:style>
+        <p:txBody>
+          <a:bodyPr rtlCol="0" anchor="ctr" wrap="square"/>
+          <a:lstStyle/>
+          <a:p>
+            <a:pPr algn="ctr">
+              <a:defRPr sz="1800" b="1">
+                <a:solidFill>
+                  <a:srgbClr val="1F6B4F"/>
+                </a:solidFill>
+                <a:latin typeface="Plus Jakarta Sans"/>
+              </a:defRPr>
+            </a:pPr>
+            <a:r>
+              <a:t>[MEME: "bro think he recyclable"]</a:t>
+            </a:r>
+          </a:p>
+          <a:p>
+            <a:pPr algn="ctr">
+              <a:spcBef>
+                <a:spcPts val="1200"/>
+              </a:spcBef>
+              <a:defRPr sz="1300">
+                <a:solidFill>
+                  <a:srgbClr val="526058"/>
+                </a:solidFill>
+                <a:latin typeface="Plus Jakarta Sans"/>
+              </a:defRPr>
+            </a:pPr>
+            <a:r>
+              <a:t>(Snack packaging trying to enter the recycling bin)</a:t>
+            </a:r>
+            <a:br/>
+            <a:br/>
+            <a:r>
+              <a:t>Drop your meme image here or delete this box</a:t>
+            </a:r>
+          </a:p>
+        </p:txBody>
+      </p:sp>
     </p:spTree>
   </p:cSld>
   <p:clrMapOvr>
@@ -5837,7 +5889,7 @@
       </p:sp>
       <p:pic>
         <p:nvPicPr>
-          <p:cNvPr id="4" name="Picture 3" descr="screen-products.png"/>
+          <p:cNvPr id="4" name="Picture 3" descr="screen-home-url.png"/>
           <p:cNvPicPr>
             <a:picLocks noChangeAspect="1"/>
           </p:cNvPicPr>
@@ -5851,8 +5903,8 @@
         </p:blipFill>
         <p:spPr>
           <a:xfrm>
-            <a:off x="6309360" y="2011680"/>
-            <a:ext cx="5029200" cy="4114800"/>
+            <a:off x="6217920" y="2560320"/>
+            <a:ext cx="5120640" cy="2465616"/>
           </a:xfrm>
           <a:prstGeom prst="rect">
             <a:avLst/>

</xml_diff>

<commit_message>
add slide 10 screenshots for antigravity vs chatgpt and sync presentation files
</commit_message>
<xml_diff>
--- a/docs/presentation/ecoloop-presentation.pptx
+++ b/docs/presentation/ecoloop-presentation.pptx
@@ -3255,16 +3255,16 @@
         </p:nvSpPr>
         <p:spPr>
           <a:xfrm>
-            <a:off x="822960" y="2103120"/>
-            <a:ext cx="5029200" cy="3840480"/>
+            <a:off x="822960" y="1965960"/>
+            <a:ext cx="5029200" cy="4434840"/>
           </a:xfrm>
           <a:prstGeom prst="rect">
             <a:avLst/>
           </a:prstGeom>
           <a:solidFill>
-            <a:srgbClr val="F8FAF8"/>
+            <a:srgbClr val="FCFCFE"/>
           </a:solidFill>
-          <a:ln w="19050">
+          <a:ln w="12700">
             <a:solidFill>
               <a:srgbClr val="E2E8E0"/>
             </a:solidFill>
@@ -3285,11 +3285,37 @@
           </a:fontRef>
         </p:style>
         <p:txBody>
-          <a:bodyPr rtlCol="0" anchor="ctr" wrap="square"/>
-          <a:lstStyle/>
-          <a:p>
-            <a:pPr algn="ctr">
-              <a:defRPr sz="1800" b="1">
+          <a:bodyPr rtlCol="0" anchor="ctr"/>
+          <a:lstStyle/>
+          <a:p>
+            <a:pPr algn="ctr"/>
+          </a:p>
+        </p:txBody>
+      </p:sp>
+      <p:sp>
+        <p:nvSpPr>
+          <p:cNvPr id="4" name="TextBox 3"/>
+          <p:cNvSpPr txBox="1"/>
+          <p:nvPr/>
+        </p:nvSpPr>
+        <p:spPr>
+          <a:xfrm>
+            <a:off x="1005840" y="2057400"/>
+            <a:ext cx="4663440" cy="320040"/>
+          </a:xfrm>
+          <a:prstGeom prst="rect">
+            <a:avLst/>
+          </a:prstGeom>
+          <a:noFill/>
+        </p:spPr>
+        <p:txBody>
+          <a:bodyPr wrap="square" lIns="0" tIns="0">
+            <a:spAutoFit/>
+          </a:bodyPr>
+          <a:lstStyle/>
+          <a:p>
+            <a:pPr>
+              <a:defRPr sz="1600" b="1">
                 <a:solidFill>
                   <a:srgbClr val="526058"/>
                 </a:solidFill>
@@ -3297,50 +3323,174 @@
               </a:defRPr>
             </a:pPr>
             <a:r>
-              <a:t>ChatGPT Web Window</a:t>
-            </a:r>
-          </a:p>
-          <a:p>
-            <a:pPr algn="ctr">
+              <a:t>ChatGPT: Web Chatbot (Isolated)</a:t>
+            </a:r>
+          </a:p>
+        </p:txBody>
+      </p:sp>
+      <p:pic>
+        <p:nvPicPr>
+          <p:cNvPr id="5" name="Picture 4" descr="screen-chatgpt.png"/>
+          <p:cNvPicPr>
+            <a:picLocks noChangeAspect="1"/>
+          </p:cNvPicPr>
+          <p:nvPr/>
+        </p:nvPicPr>
+        <p:blipFill>
+          <a:blip r:embed="rId2"/>
+          <a:stretch>
+            <a:fillRect/>
+          </a:stretch>
+        </p:blipFill>
+        <p:spPr>
+          <a:xfrm>
+            <a:off x="1371600" y="2450592"/>
+            <a:ext cx="3931920" cy="2210399"/>
+          </a:xfrm>
+          <a:prstGeom prst="rect">
+            <a:avLst/>
+          </a:prstGeom>
+        </p:spPr>
+      </p:pic>
+      <p:sp>
+        <p:nvSpPr>
+          <p:cNvPr id="6" name="TextBox 5"/>
+          <p:cNvSpPr txBox="1"/>
+          <p:nvPr/>
+        </p:nvSpPr>
+        <p:spPr>
+          <a:xfrm>
+            <a:off x="1005840" y="4709160"/>
+            <a:ext cx="4663440" cy="1600200"/>
+          </a:xfrm>
+          <a:prstGeom prst="rect">
+            <a:avLst/>
+          </a:prstGeom>
+          <a:noFill/>
+        </p:spPr>
+        <p:txBody>
+          <a:bodyPr wrap="square" lIns="0" tIns="0">
+            <a:spAutoFit/>
+          </a:bodyPr>
+          <a:lstStyle/>
+          <a:p/>
+          <a:p>
+            <a:pPr>
               <a:spcBef>
                 <a:spcPts val="1400"/>
               </a:spcBef>
-              <a:defRPr sz="1300">
+            </a:pPr>
+            <a:r>
+              <a:rPr sz="1000">
                 <a:solidFill>
                   <a:srgbClr val="526058"/>
                 </a:solidFill>
                 <a:latin typeface="Plus Jakarta Sans"/>
-              </a:defRPr>
-            </a:pPr>
-            <a:r>
-              <a:t>[DROP CHATGPT SCREENSHOT HERE]</a:t>
-            </a:r>
-            <a:br/>
-            <a:br/>
-            <a:r>
-              <a:t>• Copy-pasting snippets back and forth</a:t>
-            </a:r>
-            <a:br/>
-            <a:r>
-              <a:t>• Forgets project context easily</a:t>
-            </a:r>
-            <a:br/>
-            <a:r>
-              <a:t>• Cannot see or edit your local project files</a:t>
-            </a:r>
-          </a:p>
-        </p:txBody>
-      </p:sp>
-      <p:sp>
-        <p:nvSpPr>
-          <p:cNvPr id="4" name="Rectangle 3"/>
+              </a:rPr>
+              <a:t>■  </a:t>
+            </a:r>
+            <a:r>
+              <a:rPr sz="1500" b="1">
+                <a:solidFill>
+                  <a:srgbClr val="171A18"/>
+                </a:solidFill>
+                <a:latin typeface="Plus Jakarta Sans"/>
+              </a:rPr>
+              <a:t>Copy-Paste Loop:
+</a:t>
+            </a:r>
+            <a:r>
+              <a:rPr sz="1400">
+                <a:solidFill>
+                  <a:srgbClr val="526058"/>
+                </a:solidFill>
+                <a:latin typeface="Plus Jakarta Sans"/>
+              </a:rPr>
+              <a:t>   Generates isolated snippets you must manually copy into your editor.</a:t>
+            </a:r>
+          </a:p>
+          <a:p>
+            <a:pPr>
+              <a:spcBef>
+                <a:spcPts val="1400"/>
+              </a:spcBef>
+            </a:pPr>
+            <a:r>
+              <a:rPr sz="1000">
+                <a:solidFill>
+                  <a:srgbClr val="526058"/>
+                </a:solidFill>
+                <a:latin typeface="Plus Jakarta Sans"/>
+              </a:rPr>
+              <a:t>■  </a:t>
+            </a:r>
+            <a:r>
+              <a:rPr sz="1500" b="1">
+                <a:solidFill>
+                  <a:srgbClr val="171A18"/>
+                </a:solidFill>
+                <a:latin typeface="Plus Jakarta Sans"/>
+              </a:rPr>
+              <a:t>Zero File Access:
+</a:t>
+            </a:r>
+            <a:r>
+              <a:rPr sz="1400">
+                <a:solidFill>
+                  <a:srgbClr val="526058"/>
+                </a:solidFill>
+                <a:latin typeface="Plus Jakarta Sans"/>
+              </a:rPr>
+              <a:t>   Cannot see project folders, config files, or installed dependencies.</a:t>
+            </a:r>
+          </a:p>
+          <a:p>
+            <a:pPr>
+              <a:spcBef>
+                <a:spcPts val="1400"/>
+              </a:spcBef>
+            </a:pPr>
+            <a:r>
+              <a:rPr sz="1000">
+                <a:solidFill>
+                  <a:srgbClr val="526058"/>
+                </a:solidFill>
+                <a:latin typeface="Plus Jakarta Sans"/>
+              </a:rPr>
+              <a:t>■  </a:t>
+            </a:r>
+            <a:r>
+              <a:rPr sz="1500" b="1">
+                <a:solidFill>
+                  <a:srgbClr val="171A18"/>
+                </a:solidFill>
+                <a:latin typeface="Plus Jakarta Sans"/>
+              </a:rPr>
+              <a:t>Blind Execution:
+</a:t>
+            </a:r>
+            <a:r>
+              <a:rPr sz="1400">
+                <a:solidFill>
+                  <a:srgbClr val="526058"/>
+                </a:solidFill>
+                <a:latin typeface="Plus Jakarta Sans"/>
+              </a:rPr>
+              <a:t>   Cannot run commands, view terminal errors, or test builds.</a:t>
+            </a:r>
+          </a:p>
+        </p:txBody>
+      </p:sp>
+      <p:sp>
+        <p:nvSpPr>
+          <p:cNvPr id="7" name="Rectangle 6"/>
           <p:cNvSpPr/>
           <p:nvPr/>
         </p:nvSpPr>
         <p:spPr>
           <a:xfrm>
-            <a:off x="6309360" y="2103120"/>
-            <a:ext cx="5029200" cy="3840480"/>
+            <a:off x="6309360" y="1965960"/>
+            <a:ext cx="5029200" cy="4434840"/>
           </a:xfrm>
           <a:prstGeom prst="rect">
             <a:avLst/>
@@ -3369,11 +3519,37 @@
           </a:fontRef>
         </p:style>
         <p:txBody>
-          <a:bodyPr rtlCol="0" anchor="ctr" wrap="square"/>
-          <a:lstStyle/>
-          <a:p>
-            <a:pPr algn="ctr">
-              <a:defRPr sz="1800" b="1">
+          <a:bodyPr rtlCol="0" anchor="ctr"/>
+          <a:lstStyle/>
+          <a:p>
+            <a:pPr algn="ctr"/>
+          </a:p>
+        </p:txBody>
+      </p:sp>
+      <p:sp>
+        <p:nvSpPr>
+          <p:cNvPr id="8" name="TextBox 7"/>
+          <p:cNvSpPr txBox="1"/>
+          <p:nvPr/>
+        </p:nvSpPr>
+        <p:spPr>
+          <a:xfrm>
+            <a:off x="6492240" y="2057400"/>
+            <a:ext cx="4663440" cy="320040"/>
+          </a:xfrm>
+          <a:prstGeom prst="rect">
+            <a:avLst/>
+          </a:prstGeom>
+          <a:noFill/>
+        </p:spPr>
+        <p:txBody>
+          <a:bodyPr wrap="square" lIns="0" tIns="0">
+            <a:spAutoFit/>
+          </a:bodyPr>
+          <a:lstStyle/>
+          <a:p>
+            <a:pPr>
+              <a:defRPr sz="1600" b="1">
                 <a:solidFill>
                   <a:srgbClr val="1F6B4F"/>
                 </a:solidFill>
@@ -3381,36 +3557,160 @@
               </a:defRPr>
             </a:pPr>
             <a:r>
-              <a:t>Agent Workspace (Antigravity / OpenCode)</a:t>
-            </a:r>
-          </a:p>
-          <a:p>
-            <a:pPr algn="ctr">
+              <a:t>Antigravity: Agent Workspace (Autonomous)</a:t>
+            </a:r>
+          </a:p>
+        </p:txBody>
+      </p:sp>
+      <p:pic>
+        <p:nvPicPr>
+          <p:cNvPr id="9" name="Picture 8" descr="screen-antigravity.png"/>
+          <p:cNvPicPr>
+            <a:picLocks noChangeAspect="1"/>
+          </p:cNvPicPr>
+          <p:nvPr/>
+        </p:nvPicPr>
+        <p:blipFill>
+          <a:blip r:embed="rId3"/>
+          <a:stretch>
+            <a:fillRect/>
+          </a:stretch>
+        </p:blipFill>
+        <p:spPr>
+          <a:xfrm>
+            <a:off x="6675120" y="2761488"/>
+            <a:ext cx="4297680" cy="1575664"/>
+          </a:xfrm>
+          <a:prstGeom prst="rect">
+            <a:avLst/>
+          </a:prstGeom>
+        </p:spPr>
+      </p:pic>
+      <p:sp>
+        <p:nvSpPr>
+          <p:cNvPr id="10" name="TextBox 9"/>
+          <p:cNvSpPr txBox="1"/>
+          <p:nvPr/>
+        </p:nvSpPr>
+        <p:spPr>
+          <a:xfrm>
+            <a:off x="6492240" y="4709160"/>
+            <a:ext cx="4663440" cy="1600200"/>
+          </a:xfrm>
+          <a:prstGeom prst="rect">
+            <a:avLst/>
+          </a:prstGeom>
+          <a:noFill/>
+        </p:spPr>
+        <p:txBody>
+          <a:bodyPr wrap="square" lIns="0" tIns="0">
+            <a:spAutoFit/>
+          </a:bodyPr>
+          <a:lstStyle/>
+          <a:p/>
+          <a:p>
+            <a:pPr>
               <a:spcBef>
                 <a:spcPts val="1400"/>
               </a:spcBef>
-              <a:defRPr sz="1300">
+            </a:pPr>
+            <a:r>
+              <a:rPr sz="1000">
+                <a:solidFill>
+                  <a:srgbClr val="1F6B4F"/>
+                </a:solidFill>
+                <a:latin typeface="Plus Jakarta Sans"/>
+              </a:rPr>
+              <a:t>■  </a:t>
+            </a:r>
+            <a:r>
+              <a:rPr sz="1500" b="1">
                 <a:solidFill>
                   <a:srgbClr val="171A18"/>
                 </a:solidFill>
                 <a:latin typeface="Plus Jakarta Sans"/>
-              </a:defRPr>
-            </a:pPr>
-            <a:r>
-              <a:t>[DROP ANTIGRAVITY SCREENSHOT HERE]</a:t>
-            </a:r>
-            <a:br/>
-            <a:br/>
-            <a:r>
-              <a:t>• Reads and edits real repository files</a:t>
-            </a:r>
-            <a:br/>
-            <a:r>
-              <a:t>• Understands full folder structure and context</a:t>
-            </a:r>
-            <a:br/>
-            <a:r>
-              <a:t>• Runs terminal builds and tests autonomously</a:t>
+              </a:rPr>
+              <a:t>Direct Repository Edits:
+</a:t>
+            </a:r>
+            <a:r>
+              <a:rPr sz="1400">
+                <a:solidFill>
+                  <a:srgbClr val="526058"/>
+                </a:solidFill>
+                <a:latin typeface="Plus Jakarta Sans"/>
+              </a:rPr>
+              <a:t>   Inspects folder context and writes multi-file modifications directly.</a:t>
+            </a:r>
+          </a:p>
+          <a:p>
+            <a:pPr>
+              <a:spcBef>
+                <a:spcPts val="1400"/>
+              </a:spcBef>
+            </a:pPr>
+            <a:r>
+              <a:rPr sz="1000">
+                <a:solidFill>
+                  <a:srgbClr val="1F6B4F"/>
+                </a:solidFill>
+                <a:latin typeface="Plus Jakarta Sans"/>
+              </a:rPr>
+              <a:t>■  </a:t>
+            </a:r>
+            <a:r>
+              <a:rPr sz="1500" b="1">
+                <a:solidFill>
+                  <a:srgbClr val="171A18"/>
+                </a:solidFill>
+                <a:latin typeface="Plus Jakarta Sans"/>
+              </a:rPr>
+              <a:t>Autonomous Terminal:
+</a:t>
+            </a:r>
+            <a:r>
+              <a:rPr sz="1400">
+                <a:solidFill>
+                  <a:srgbClr val="526058"/>
+                </a:solidFill>
+                <a:latin typeface="Plus Jakarta Sans"/>
+              </a:rPr>
+              <a:t>   Runs shell commands, dev servers, and build tests in the workspace.</a:t>
+            </a:r>
+          </a:p>
+          <a:p>
+            <a:pPr>
+              <a:spcBef>
+                <a:spcPts val="1400"/>
+              </a:spcBef>
+            </a:pPr>
+            <a:r>
+              <a:rPr sz="1000">
+                <a:solidFill>
+                  <a:srgbClr val="1F6B4F"/>
+                </a:solidFill>
+                <a:latin typeface="Plus Jakarta Sans"/>
+              </a:rPr>
+              <a:t>■  </a:t>
+            </a:r>
+            <a:r>
+              <a:rPr sz="1500" b="1">
+                <a:solidFill>
+                  <a:srgbClr val="171A18"/>
+                </a:solidFill>
+                <a:latin typeface="Plus Jakarta Sans"/>
+              </a:rPr>
+              <a:t>Self-Repair Loop:
+</a:t>
+            </a:r>
+            <a:r>
+              <a:rPr sz="1400">
+                <a:solidFill>
+                  <a:srgbClr val="526058"/>
+                </a:solidFill>
+                <a:latin typeface="Plus Jakarta Sans"/>
+              </a:rPr>
+              <a:t>   Catches compiler and runtime errors and fixes them automatically.</a:t>
             </a:r>
           </a:p>
         </p:txBody>

</xml_diff>

<commit_message>
update meme slides with big memes, custom titles, and clean chatgpt landing screen
</commit_message>
<xml_diff>
--- a/docs/presentation/ecoloop-presentation.pptx
+++ b/docs/presentation/ecoloop-presentation.pptx
@@ -3345,7 +3345,7 @@
         <p:spPr>
           <a:xfrm>
             <a:off x="1371600" y="2450592"/>
-            <a:ext cx="3931920" cy="2210399"/>
+            <a:ext cx="3931920" cy="1597342"/>
           </a:xfrm>
           <a:prstGeom prst="rect">
             <a:avLst/>
@@ -4854,8 +4854,8 @@
         </p:nvSpPr>
         <p:spPr>
           <a:xfrm>
-            <a:off x="1371600" y="731520"/>
-            <a:ext cx="9418320" cy="822960"/>
+            <a:off x="914400" y="594360"/>
+            <a:ext cx="10332720" cy="777240"/>
           </a:xfrm>
           <a:prstGeom prst="rect">
             <a:avLst/>
@@ -4869,7 +4869,7 @@
           <a:lstStyle/>
           <a:p>
             <a:pPr algn="ctr">
-              <a:defRPr sz="3200" b="1">
+              <a:defRPr sz="3000" b="1">
                 <a:solidFill>
                   <a:srgbClr val="171A18"/>
                 </a:solidFill>
@@ -4877,82 +4877,35 @@
               </a:defRPr>
             </a:pPr>
             <a:r>
-              <a:t>Reality Check: AI Confidence vs Reality</a:t>
-            </a:r>
-          </a:p>
-        </p:txBody>
-      </p:sp>
-      <p:sp>
-        <p:nvSpPr>
-          <p:cNvPr id="3" name="Rectangle 2"/>
-          <p:cNvSpPr/>
+              <a:t>deployed without testing</a:t>
+            </a:r>
+          </a:p>
+        </p:txBody>
+      </p:sp>
+      <p:pic>
+        <p:nvPicPr>
+          <p:cNvPr id="3" name="Picture 2" descr="nochecking.jpg"/>
+          <p:cNvPicPr>
+            <a:picLocks noChangeAspect="1"/>
+          </p:cNvPicPr>
           <p:nvPr/>
-        </p:nvSpPr>
+        </p:nvPicPr>
+        <p:blipFill>
+          <a:blip r:embed="rId2"/>
+          <a:stretch>
+            <a:fillRect/>
+          </a:stretch>
+        </p:blipFill>
         <p:spPr>
           <a:xfrm>
-            <a:off x="2560320" y="1645920"/>
-            <a:ext cx="7040880" cy="3931920"/>
+            <a:off x="3474709" y="1554480"/>
+            <a:ext cx="5239533" cy="3931920"/>
           </a:xfrm>
           <a:prstGeom prst="rect">
             <a:avLst/>
           </a:prstGeom>
-          <a:solidFill>
-            <a:srgbClr val="F8FAF8"/>
-          </a:solidFill>
-          <a:ln w="19050">
-            <a:solidFill>
-              <a:srgbClr val="1F6B4F"/>
-            </a:solidFill>
-          </a:ln>
         </p:spPr>
-        <p:style>
-          <a:lnRef idx="1">
-            <a:schemeClr val="accent1"/>
-          </a:lnRef>
-          <a:fillRef idx="3">
-            <a:schemeClr val="accent1"/>
-          </a:fillRef>
-          <a:effectRef idx="2">
-            <a:schemeClr val="accent1"/>
-          </a:effectRef>
-          <a:fontRef idx="minor">
-            <a:schemeClr val="lt1"/>
-          </a:fontRef>
-        </p:style>
-        <p:txBody>
-          <a:bodyPr rtlCol="0" anchor="ctr" wrap="square"/>
-          <a:lstStyle/>
-          <a:p>
-            <a:pPr algn="ctr">
-              <a:defRPr sz="1800" b="1">
-                <a:solidFill>
-                  <a:srgbClr val="1F6B4F"/>
-                </a:solidFill>
-                <a:latin typeface="Plus Jakarta Sans"/>
-              </a:defRPr>
-            </a:pPr>
-            <a:r>
-              <a:t>[MEME 04: AI confidently saying 'all bugs fixed' vs Clicking the button and the console explodes]</a:t>
-            </a:r>
-          </a:p>
-          <a:p>
-            <a:pPr algn="ctr">
-              <a:spcBef>
-                <a:spcPts val="800"/>
-              </a:spcBef>
-              <a:defRPr sz="1300">
-                <a:solidFill>
-                  <a:srgbClr val="526058"/>
-                </a:solidFill>
-                <a:latin typeface="Plus Jakarta Sans"/>
-              </a:defRPr>
-            </a:pPr>
-            <a:r>
-              <a:t>(Drop your meme image here or delete this box)</a:t>
-            </a:r>
-          </a:p>
-        </p:txBody>
-      </p:sp>
+      </p:pic>
       <p:sp>
         <p:nvSpPr>
           <p:cNvPr id="4" name="TextBox 3"/>
@@ -4961,8 +4914,8 @@
         </p:nvSpPr>
         <p:spPr>
           <a:xfrm>
-            <a:off x="2286000" y="5760720"/>
-            <a:ext cx="7589520" cy="731520"/>
+            <a:off x="1645920" y="5687568"/>
+            <a:ext cx="8869680" cy="731520"/>
           </a:xfrm>
           <a:prstGeom prst="rect">
             <a:avLst/>
@@ -4976,7 +4929,7 @@
           <a:lstStyle/>
           <a:p>
             <a:pPr algn="ctr">
-              <a:defRPr sz="1500">
+              <a:defRPr sz="1400">
                 <a:solidFill>
                   <a:srgbClr val="526058"/>
                 </a:solidFill>
@@ -4984,7 +4937,7 @@
               </a:defRPr>
             </a:pPr>
             <a:r>
-              <a:t>Prompting is only 20% of the work. Testing whether the buttons actually work is the other 80%.</a:t>
+              <a:t>Prompting is only 20% of the work. Clicking every button to see what actually broke is the other 80%.</a:t>
             </a:r>
           </a:p>
         </p:txBody>
@@ -5841,8 +5794,8 @@
         </p:nvSpPr>
         <p:spPr>
           <a:xfrm>
-            <a:off x="1371600" y="731520"/>
-            <a:ext cx="9418320" cy="822960"/>
+            <a:off x="914400" y="594360"/>
+            <a:ext cx="10332720" cy="777240"/>
           </a:xfrm>
           <a:prstGeom prst="rect">
             <a:avLst/>
@@ -5856,7 +5809,7 @@
           <a:lstStyle/>
           <a:p>
             <a:pPr algn="ctr">
-              <a:defRPr sz="3200" b="1">
+              <a:defRPr sz="3000" b="1">
                 <a:solidFill>
                   <a:srgbClr val="171A18"/>
                 </a:solidFill>
@@ -5864,82 +5817,35 @@
               </a:defRPr>
             </a:pPr>
             <a:r>
-              <a:t>Reality Check: How It Started vs How It Is Going</a:t>
-            </a:r>
-          </a:p>
-        </p:txBody>
-      </p:sp>
-      <p:sp>
-        <p:nvSpPr>
-          <p:cNvPr id="3" name="Rectangle 2"/>
-          <p:cNvSpPr/>
+              <a:t>how it started vs how it's going</a:t>
+            </a:r>
+          </a:p>
+        </p:txBody>
+      </p:sp>
+      <p:pic>
+        <p:nvPicPr>
+          <p:cNvPr id="3" name="Picture 2" descr="reality-check.jpg"/>
+          <p:cNvPicPr>
+            <a:picLocks noChangeAspect="1"/>
+          </p:cNvPicPr>
           <p:nvPr/>
-        </p:nvSpPr>
+        </p:nvPicPr>
+        <p:blipFill>
+          <a:blip r:embed="rId2"/>
+          <a:stretch>
+            <a:fillRect/>
+          </a:stretch>
+        </p:blipFill>
         <p:spPr>
           <a:xfrm>
-            <a:off x="2560320" y="1645920"/>
-            <a:ext cx="7040880" cy="3931920"/>
+            <a:off x="4128516" y="1554480"/>
+            <a:ext cx="3931920" cy="3931920"/>
           </a:xfrm>
           <a:prstGeom prst="rect">
             <a:avLst/>
           </a:prstGeom>
-          <a:solidFill>
-            <a:srgbClr val="F8FAF8"/>
-          </a:solidFill>
-          <a:ln w="19050">
-            <a:solidFill>
-              <a:srgbClr val="1F6B4F"/>
-            </a:solidFill>
-          </a:ln>
         </p:spPr>
-        <p:style>
-          <a:lnRef idx="1">
-            <a:schemeClr val="accent1"/>
-          </a:lnRef>
-          <a:fillRef idx="3">
-            <a:schemeClr val="accent1"/>
-          </a:fillRef>
-          <a:effectRef idx="2">
-            <a:schemeClr val="accent1"/>
-          </a:effectRef>
-          <a:fontRef idx="minor">
-            <a:schemeClr val="lt1"/>
-          </a:fontRef>
-        </p:style>
-        <p:txBody>
-          <a:bodyPr rtlCol="0" anchor="ctr" wrap="square"/>
-          <a:lstStyle/>
-          <a:p>
-            <a:pPr algn="ctr">
-              <a:defRPr sz="1800" b="1">
-                <a:solidFill>
-                  <a:srgbClr val="1F6B4F"/>
-                </a:solidFill>
-                <a:latin typeface="Plus Jakarta Sans"/>
-              </a:defRPr>
-            </a:pPr>
-            <a:r>
-              <a:t>[MEME 01: Teachers thinking we'd just pick up litter vs Building a brand &amp; platform]</a:t>
-            </a:r>
-          </a:p>
-          <a:p>
-            <a:pPr algn="ctr">
-              <a:spcBef>
-                <a:spcPts val="800"/>
-              </a:spcBef>
-              <a:defRPr sz="1300">
-                <a:solidFill>
-                  <a:srgbClr val="526058"/>
-                </a:solidFill>
-                <a:latin typeface="Plus Jakarta Sans"/>
-              </a:defRPr>
-            </a:pPr>
-            <a:r>
-              <a:t>(Drop your meme image here or delete this box)</a:t>
-            </a:r>
-          </a:p>
-        </p:txBody>
-      </p:sp>
+      </p:pic>
       <p:sp>
         <p:nvSpPr>
           <p:cNvPr id="4" name="TextBox 3"/>
@@ -5948,8 +5854,8 @@
         </p:nvSpPr>
         <p:spPr>
           <a:xfrm>
-            <a:off x="2286000" y="5760720"/>
-            <a:ext cx="7589520" cy="731520"/>
+            <a:off x="1645920" y="5687568"/>
+            <a:ext cx="8869680" cy="731520"/>
           </a:xfrm>
           <a:prstGeom prst="rect">
             <a:avLst/>
@@ -5963,7 +5869,7 @@
           <a:lstStyle/>
           <a:p>
             <a:pPr algn="ctr">
-              <a:defRPr sz="1500">
+              <a:defRPr sz="1400">
                 <a:solidFill>
                   <a:srgbClr val="526058"/>
                 </a:solidFill>
@@ -6641,8 +6547,8 @@
         </p:nvSpPr>
         <p:spPr>
           <a:xfrm>
-            <a:off x="1371600" y="731520"/>
-            <a:ext cx="9418320" cy="822960"/>
+            <a:off x="914400" y="594360"/>
+            <a:ext cx="10332720" cy="777240"/>
           </a:xfrm>
           <a:prstGeom prst="rect">
             <a:avLst/>
@@ -6656,7 +6562,7 @@
           <a:lstStyle/>
           <a:p>
             <a:pPr algn="ctr">
-              <a:defRPr sz="3200" b="1">
+              <a:defRPr sz="3000" b="1">
                 <a:solidFill>
                   <a:srgbClr val="171A18"/>
                 </a:solidFill>
@@ -6664,82 +6570,35 @@
               </a:defRPr>
             </a:pPr>
             <a:r>
-              <a:t>Reality Check: The Cloud Bill Dilemma</a:t>
-            </a:r>
-          </a:p>
-        </p:txBody>
-      </p:sp>
-      <p:sp>
-        <p:nvSpPr>
-          <p:cNvPr id="3" name="Rectangle 2"/>
-          <p:cNvSpPr/>
+              <a:t>why our database bill is literally $0</a:t>
+            </a:r>
+          </a:p>
+        </p:txBody>
+      </p:sp>
+      <p:pic>
+        <p:nvPicPr>
+          <p:cNvPr id="3" name="Picture 2" descr="buff-jack.jpeg"/>
+          <p:cNvPicPr>
+            <a:picLocks noChangeAspect="1"/>
+          </p:cNvPicPr>
           <p:nvPr/>
-        </p:nvSpPr>
+        </p:nvPicPr>
+        <p:blipFill>
+          <a:blip r:embed="rId2"/>
+          <a:stretch>
+            <a:fillRect/>
+          </a:stretch>
+        </p:blipFill>
         <p:spPr>
           <a:xfrm>
-            <a:off x="2560320" y="1645920"/>
-            <a:ext cx="7040880" cy="3931920"/>
+            <a:off x="4123035" y="1554480"/>
+            <a:ext cx="3942882" cy="3931920"/>
           </a:xfrm>
           <a:prstGeom prst="rect">
             <a:avLst/>
           </a:prstGeom>
-          <a:solidFill>
-            <a:srgbClr val="F8FAF8"/>
-          </a:solidFill>
-          <a:ln w="19050">
-            <a:solidFill>
-              <a:srgbClr val="1F6B4F"/>
-            </a:solidFill>
-          </a:ln>
         </p:spPr>
-        <p:style>
-          <a:lnRef idx="1">
-            <a:schemeClr val="accent1"/>
-          </a:lnRef>
-          <a:fillRef idx="3">
-            <a:schemeClr val="accent1"/>
-          </a:fillRef>
-          <a:effectRef idx="2">
-            <a:schemeClr val="accent1"/>
-          </a:effectRef>
-          <a:fontRef idx="minor">
-            <a:schemeClr val="lt1"/>
-          </a:fontRef>
-        </p:style>
-        <p:txBody>
-          <a:bodyPr rtlCol="0" anchor="ctr" wrap="square"/>
-          <a:lstStyle/>
-          <a:p>
-            <a:pPr algn="ctr">
-              <a:defRPr sz="1800" b="1">
-                <a:solidFill>
-                  <a:srgbClr val="1F6B4F"/>
-                </a:solidFill>
-                <a:latin typeface="Plus Jakarta Sans"/>
-              </a:defRPr>
-            </a:pPr>
-            <a:r>
-              <a:t>[MEME 02: Paying $50/month for cloud databases vs High schoolers using a free Google Sheet]</a:t>
-            </a:r>
-          </a:p>
-          <a:p>
-            <a:pPr algn="ctr">
-              <a:spcBef>
-                <a:spcPts val="800"/>
-              </a:spcBef>
-              <a:defRPr sz="1300">
-                <a:solidFill>
-                  <a:srgbClr val="526058"/>
-                </a:solidFill>
-                <a:latin typeface="Plus Jakarta Sans"/>
-              </a:defRPr>
-            </a:pPr>
-            <a:r>
-              <a:t>(Drop your meme image here or delete this box)</a:t>
-            </a:r>
-          </a:p>
-        </p:txBody>
-      </p:sp>
+      </p:pic>
       <p:sp>
         <p:nvSpPr>
           <p:cNvPr id="4" name="TextBox 3"/>
@@ -6748,8 +6607,8 @@
         </p:nvSpPr>
         <p:spPr>
           <a:xfrm>
-            <a:off x="2286000" y="5760720"/>
-            <a:ext cx="7589520" cy="731520"/>
+            <a:off x="1645920" y="5687568"/>
+            <a:ext cx="8869680" cy="731520"/>
           </a:xfrm>
           <a:prstGeom prst="rect">
             <a:avLst/>
@@ -6763,7 +6622,7 @@
           <a:lstStyle/>
           <a:p>
             <a:pPr algn="ctr">
-              <a:defRPr sz="1500">
+              <a:defRPr sz="1400">
                 <a:solidFill>
                   <a:srgbClr val="526058"/>
                 </a:solidFill>
@@ -6771,7 +6630,7 @@
               </a:defRPr>
             </a:pPr>
             <a:r>
-              <a:t>Why spend monthly money on complex database servers when a free Google Sheet captures all your orders?</a:t>
+              <a:t>Why spend monthly money on complex database servers when a free Google Sheet captures all your incoming inquiries?</a:t>
             </a:r>
           </a:p>
         </p:txBody>

</xml_diff>

<commit_message>
update slide 3 to 3x2 product grid and retake slide 5 live ecoloop homepage capture
</commit_message>
<xml_diff>
--- a/docs/presentation/ecoloop-presentation.pptx
+++ b/docs/presentation/ecoloop-presentation.pptx
@@ -5513,205 +5513,31 @@
               </a:defRPr>
             </a:pPr>
             <a:r>
-              <a:t>Six circular products systematically diverted from waste streams.</a:t>
-            </a:r>
-          </a:p>
-        </p:txBody>
-      </p:sp>
-      <p:sp>
-        <p:nvSpPr>
-          <p:cNvPr id="3" name="TextBox 2"/>
-          <p:cNvSpPr txBox="1"/>
-          <p:nvPr/>
-        </p:nvSpPr>
-        <p:spPr>
-          <a:xfrm>
-            <a:off x="822960" y="2011680"/>
-            <a:ext cx="5120640" cy="4389120"/>
-          </a:xfrm>
-          <a:prstGeom prst="rect">
-            <a:avLst/>
-          </a:prstGeom>
-          <a:noFill/>
-        </p:spPr>
-        <p:txBody>
-          <a:bodyPr wrap="square" lIns="0" tIns="0">
-            <a:spAutoFit/>
-          </a:bodyPr>
-          <a:lstStyle/>
-          <a:p>
-            <a:r>
-              <a:rPr sz="1450" b="1">
-                <a:solidFill>
-                  <a:srgbClr val="1F6B4F"/>
-                </a:solidFill>
-                <a:latin typeface="Plus Jakarta Sans"/>
-              </a:rPr>
-              <a:t>■  Student-Made: Seed Paper
-</a:t>
-            </a:r>
-            <a:r>
-              <a:rPr sz="1300">
-                <a:solidFill>
-                  <a:srgbClr val="526058"/>
-                </a:solidFill>
-                <a:latin typeface="Plus Jakarta Sans"/>
-              </a:rPr>
-              <a:t>   Handmade plantable paper embedded with native seeds, crafted in school.</a:t>
-            </a:r>
-          </a:p>
-          <a:p>
-            <a:pPr>
-              <a:spcBef>
-                <a:spcPts val="1100"/>
-              </a:spcBef>
-            </a:pPr>
-            <a:r>
-              <a:rPr sz="1450" b="1">
-                <a:solidFill>
-                  <a:srgbClr val="1F6B4F"/>
-                </a:solidFill>
-                <a:latin typeface="Plus Jakarta Sans"/>
-              </a:rPr>
-              <a:t>■  Student-Made: Bioenzymes
-</a:t>
-            </a:r>
-            <a:r>
-              <a:rPr sz="1300">
-                <a:solidFill>
-                  <a:srgbClr val="526058"/>
-                </a:solidFill>
-                <a:latin typeface="Plus Jakarta Sans"/>
-              </a:rPr>
-              <a:t>   Citrus fruit peels fermented into natural multi-purpose cleaning liquids.</a:t>
-            </a:r>
-          </a:p>
-          <a:p>
-            <a:pPr>
-              <a:spcBef>
-                <a:spcPts val="1100"/>
-              </a:spcBef>
-            </a:pPr>
-            <a:r>
-              <a:rPr sz="1450" b="1">
-                <a:solidFill>
-                  <a:srgbClr val="1F6B4F"/>
-                </a:solidFill>
-                <a:latin typeface="Plus Jakarta Sans"/>
-              </a:rPr>
-              <a:t>■  Student-Made: Uniform Bags
-</a:t>
-            </a:r>
-            <a:r>
-              <a:rPr sz="1300">
-                <a:solidFill>
-                  <a:srgbClr val="526058"/>
-                </a:solidFill>
-                <a:latin typeface="Plus Jakarta Sans"/>
-              </a:rPr>
-              <a:t>   Durable tote bags stitched from discarded school uniform fabrics.</a:t>
-            </a:r>
-          </a:p>
-          <a:p>
-            <a:pPr>
-              <a:spcBef>
-                <a:spcPts val="1100"/>
-              </a:spcBef>
-            </a:pPr>
-            <a:r>
-              <a:rPr sz="1450" b="1">
-                <a:solidFill>
-                  <a:srgbClr val="1F6B4F"/>
-                </a:solidFill>
-                <a:latin typeface="Plus Jakarta Sans"/>
-              </a:rPr>
-              <a:t>■  Student-Made: Eco-Bricks
-</a:t>
-            </a:r>
-            <a:r>
-              <a:rPr sz="1300">
-                <a:solidFill>
-                  <a:srgbClr val="526058"/>
-                </a:solidFill>
-                <a:latin typeface="Plus Jakarta Sans"/>
-              </a:rPr>
-              <a:t>   PET bottles tightly packed with clean plastic wrappers for simple construction.</a:t>
-            </a:r>
-          </a:p>
-          <a:p>
-            <a:pPr>
-              <a:spcBef>
-                <a:spcPts val="1100"/>
-              </a:spcBef>
-            </a:pPr>
-            <a:r>
-              <a:rPr sz="1450" b="1">
-                <a:solidFill>
-                  <a:srgbClr val="1F6B4F"/>
-                </a:solidFill>
-                <a:latin typeface="Plus Jakarta Sans"/>
-              </a:rPr>
-              <a:t>■  Student-Made: Bottle Planters
-</a:t>
-            </a:r>
-            <a:r>
-              <a:rPr sz="1300">
-                <a:solidFill>
-                  <a:srgbClr val="526058"/>
-                </a:solidFill>
-                <a:latin typeface="Plus Jakarta Sans"/>
-              </a:rPr>
-              <a:t>   Upcycled beverage containers for school corridor nursery gardening.</a:t>
-            </a:r>
-          </a:p>
-          <a:p>
-            <a:pPr>
-              <a:spcBef>
-                <a:spcPts val="1100"/>
-              </a:spcBef>
-            </a:pPr>
-            <a:r>
-              <a:rPr sz="1450" b="1">
-                <a:solidFill>
-                  <a:srgbClr val="288563"/>
-                </a:solidFill>
-                <a:latin typeface="Plus Jakarta Sans"/>
-              </a:rPr>
-              <a:t>■  NGO Partnership: MLP Sheets
-</a:t>
-            </a:r>
-            <a:r>
-              <a:rPr sz="1300">
-                <a:solidFill>
-                  <a:srgbClr val="526058"/>
-                </a:solidFill>
-                <a:latin typeface="Plus Jakarta Sans"/>
-              </a:rPr>
-              <a:t>   Heavy-duty boards heat-pressed from snack wrappers using hydraulic machinery.</a:t>
-            </a:r>
-          </a:p>
-        </p:txBody>
-      </p:sp>
-      <p:sp>
-        <p:nvSpPr>
-          <p:cNvPr id="4" name="Rectangle 3"/>
+              <a:t>Six circular products systematically diverted from school waste streams.</a:t>
+            </a:r>
+          </a:p>
+        </p:txBody>
+      </p:sp>
+      <p:sp>
+        <p:nvSpPr>
+          <p:cNvPr id="3" name="Rectangle 2"/>
           <p:cNvSpPr/>
           <p:nvPr/>
         </p:nvSpPr>
         <p:spPr>
           <a:xfrm>
-            <a:off x="6309360" y="2011680"/>
-            <a:ext cx="5029200" cy="4114800"/>
+            <a:off x="822960" y="2103120"/>
+            <a:ext cx="3291840" cy="1965960"/>
           </a:xfrm>
           <a:prstGeom prst="rect">
             <a:avLst/>
           </a:prstGeom>
           <a:solidFill>
-            <a:srgbClr val="F0F6F2"/>
+            <a:srgbClr val="F8FAF8"/>
           </a:solidFill>
-          <a:ln w="19050">
+          <a:ln w="12700">
             <a:solidFill>
-              <a:srgbClr val="1F6B4F"/>
+              <a:srgbClr val="E2E8E0"/>
             </a:solidFill>
           </a:ln>
         </p:spPr>
@@ -5730,27 +5556,478 @@
           </a:fontRef>
         </p:style>
         <p:txBody>
-          <a:bodyPr rtlCol="0" anchor="ctr" wrap="square"/>
+          <a:bodyPr rtlCol="0" anchor="ctr" wrap="square" lIns="182880" rIns="182880" tIns="164592"/>
           <a:lstStyle/>
           <a:p>
             <a:pPr algn="ctr">
-              <a:defRPr sz="1800" b="1">
+              <a:defRPr sz="1000" b="1">
+                <a:solidFill>
+                  <a:srgbClr val="526058"/>
+                </a:solidFill>
+                <a:latin typeface="JetBrains Mono"/>
+              </a:defRPr>
+            </a:pPr>
+            <a:r>
+              <a:t>STUDENT-MADE</a:t>
+            </a:r>
+          </a:p>
+          <a:p>
+            <a:pPr>
+              <a:spcBef>
+                <a:spcPts val="400"/>
+              </a:spcBef>
+              <a:defRPr sz="1700" b="1">
+                <a:solidFill>
+                  <a:srgbClr val="171A18"/>
+                </a:solidFill>
+                <a:latin typeface="Plus Jakarta Sans"/>
+              </a:defRPr>
+            </a:pPr>
+            <a:r>
+              <a:t>Seed Paper</a:t>
+            </a:r>
+          </a:p>
+          <a:p>
+            <a:pPr>
+              <a:spcBef>
+                <a:spcPts val="600"/>
+              </a:spcBef>
+              <a:defRPr sz="1200">
+                <a:solidFill>
+                  <a:srgbClr val="526058"/>
+                </a:solidFill>
+                <a:latin typeface="Plus Jakarta Sans"/>
+              </a:defRPr>
+            </a:pPr>
+            <a:r>
+              <a:t>Handmade plantable paper embedded with native seeds, crafted directly inside school.</a:t>
+            </a:r>
+          </a:p>
+        </p:txBody>
+      </p:sp>
+      <p:sp>
+        <p:nvSpPr>
+          <p:cNvPr id="4" name="Rectangle 3"/>
+          <p:cNvSpPr/>
+          <p:nvPr/>
+        </p:nvSpPr>
+        <p:spPr>
+          <a:xfrm>
+            <a:off x="4480560" y="2103120"/>
+            <a:ext cx="3291840" cy="1965960"/>
+          </a:xfrm>
+          <a:prstGeom prst="rect">
+            <a:avLst/>
+          </a:prstGeom>
+          <a:solidFill>
+            <a:srgbClr val="F8FAF8"/>
+          </a:solidFill>
+          <a:ln w="12700">
+            <a:solidFill>
+              <a:srgbClr val="E2E8E0"/>
+            </a:solidFill>
+          </a:ln>
+        </p:spPr>
+        <p:style>
+          <a:lnRef idx="1">
+            <a:schemeClr val="accent1"/>
+          </a:lnRef>
+          <a:fillRef idx="3">
+            <a:schemeClr val="accent1"/>
+          </a:fillRef>
+          <a:effectRef idx="2">
+            <a:schemeClr val="accent1"/>
+          </a:effectRef>
+          <a:fontRef idx="minor">
+            <a:schemeClr val="lt1"/>
+          </a:fontRef>
+        </p:style>
+        <p:txBody>
+          <a:bodyPr rtlCol="0" anchor="ctr" wrap="square" lIns="182880" rIns="182880" tIns="164592"/>
+          <a:lstStyle/>
+          <a:p>
+            <a:pPr algn="ctr">
+              <a:defRPr sz="1000" b="1">
+                <a:solidFill>
+                  <a:srgbClr val="526058"/>
+                </a:solidFill>
+                <a:latin typeface="JetBrains Mono"/>
+              </a:defRPr>
+            </a:pPr>
+            <a:r>
+              <a:t>STUDENT-MADE</a:t>
+            </a:r>
+          </a:p>
+          <a:p>
+            <a:pPr>
+              <a:spcBef>
+                <a:spcPts val="400"/>
+              </a:spcBef>
+              <a:defRPr sz="1700" b="1">
+                <a:solidFill>
+                  <a:srgbClr val="171A18"/>
+                </a:solidFill>
+                <a:latin typeface="Plus Jakarta Sans"/>
+              </a:defRPr>
+            </a:pPr>
+            <a:r>
+              <a:t>Bioenzymes</a:t>
+            </a:r>
+          </a:p>
+          <a:p>
+            <a:pPr>
+              <a:spcBef>
+                <a:spcPts val="600"/>
+              </a:spcBef>
+              <a:defRPr sz="1200">
+                <a:solidFill>
+                  <a:srgbClr val="526058"/>
+                </a:solidFill>
+                <a:latin typeface="Plus Jakarta Sans"/>
+              </a:defRPr>
+            </a:pPr>
+            <a:r>
+              <a:t>Citrus fruit peels fermented into natural multi-purpose cleaning liquids for campus sanitation.</a:t>
+            </a:r>
+          </a:p>
+        </p:txBody>
+      </p:sp>
+      <p:sp>
+        <p:nvSpPr>
+          <p:cNvPr id="5" name="Rectangle 4"/>
+          <p:cNvSpPr/>
+          <p:nvPr/>
+        </p:nvSpPr>
+        <p:spPr>
+          <a:xfrm>
+            <a:off x="8138160" y="2103120"/>
+            <a:ext cx="3291840" cy="1965960"/>
+          </a:xfrm>
+          <a:prstGeom prst="rect">
+            <a:avLst/>
+          </a:prstGeom>
+          <a:solidFill>
+            <a:srgbClr val="F8FAF8"/>
+          </a:solidFill>
+          <a:ln w="12700">
+            <a:solidFill>
+              <a:srgbClr val="E2E8E0"/>
+            </a:solidFill>
+          </a:ln>
+        </p:spPr>
+        <p:style>
+          <a:lnRef idx="1">
+            <a:schemeClr val="accent1"/>
+          </a:lnRef>
+          <a:fillRef idx="3">
+            <a:schemeClr val="accent1"/>
+          </a:fillRef>
+          <a:effectRef idx="2">
+            <a:schemeClr val="accent1"/>
+          </a:effectRef>
+          <a:fontRef idx="minor">
+            <a:schemeClr val="lt1"/>
+          </a:fontRef>
+        </p:style>
+        <p:txBody>
+          <a:bodyPr rtlCol="0" anchor="ctr" wrap="square" lIns="182880" rIns="182880" tIns="164592"/>
+          <a:lstStyle/>
+          <a:p>
+            <a:pPr algn="ctr">
+              <a:defRPr sz="1000" b="1">
+                <a:solidFill>
+                  <a:srgbClr val="526058"/>
+                </a:solidFill>
+                <a:latin typeface="JetBrains Mono"/>
+              </a:defRPr>
+            </a:pPr>
+            <a:r>
+              <a:t>STUDENT-MADE</a:t>
+            </a:r>
+          </a:p>
+          <a:p>
+            <a:pPr>
+              <a:spcBef>
+                <a:spcPts val="400"/>
+              </a:spcBef>
+              <a:defRPr sz="1700" b="1">
+                <a:solidFill>
+                  <a:srgbClr val="171A18"/>
+                </a:solidFill>
+                <a:latin typeface="Plus Jakarta Sans"/>
+              </a:defRPr>
+            </a:pPr>
+            <a:r>
+              <a:t>Uniform Bags</a:t>
+            </a:r>
+          </a:p>
+          <a:p>
+            <a:pPr>
+              <a:spcBef>
+                <a:spcPts val="600"/>
+              </a:spcBef>
+              <a:defRPr sz="1200">
+                <a:solidFill>
+                  <a:srgbClr val="526058"/>
+                </a:solidFill>
+                <a:latin typeface="Plus Jakarta Sans"/>
+              </a:defRPr>
+            </a:pPr>
+            <a:r>
+              <a:t>Durable everyday tote bags stitched from discarded school uniform fabrics.</a:t>
+            </a:r>
+          </a:p>
+        </p:txBody>
+      </p:sp>
+      <p:sp>
+        <p:nvSpPr>
+          <p:cNvPr id="6" name="Rectangle 5"/>
+          <p:cNvSpPr/>
+          <p:nvPr/>
+        </p:nvSpPr>
+        <p:spPr>
+          <a:xfrm>
+            <a:off x="822960" y="4389120"/>
+            <a:ext cx="3291840" cy="1965960"/>
+          </a:xfrm>
+          <a:prstGeom prst="rect">
+            <a:avLst/>
+          </a:prstGeom>
+          <a:solidFill>
+            <a:srgbClr val="F8FAF8"/>
+          </a:solidFill>
+          <a:ln w="12700">
+            <a:solidFill>
+              <a:srgbClr val="E2E8E0"/>
+            </a:solidFill>
+          </a:ln>
+        </p:spPr>
+        <p:style>
+          <a:lnRef idx="1">
+            <a:schemeClr val="accent1"/>
+          </a:lnRef>
+          <a:fillRef idx="3">
+            <a:schemeClr val="accent1"/>
+          </a:fillRef>
+          <a:effectRef idx="2">
+            <a:schemeClr val="accent1"/>
+          </a:effectRef>
+          <a:fontRef idx="minor">
+            <a:schemeClr val="lt1"/>
+          </a:fontRef>
+        </p:style>
+        <p:txBody>
+          <a:bodyPr rtlCol="0" anchor="ctr" wrap="square" lIns="182880" rIns="182880" tIns="164592"/>
+          <a:lstStyle/>
+          <a:p>
+            <a:pPr algn="ctr">
+              <a:defRPr sz="1000" b="1">
+                <a:solidFill>
+                  <a:srgbClr val="526058"/>
+                </a:solidFill>
+                <a:latin typeface="JetBrains Mono"/>
+              </a:defRPr>
+            </a:pPr>
+            <a:r>
+              <a:t>STUDENT-MADE</a:t>
+            </a:r>
+          </a:p>
+          <a:p>
+            <a:pPr>
+              <a:spcBef>
+                <a:spcPts val="400"/>
+              </a:spcBef>
+              <a:defRPr sz="1700" b="1">
+                <a:solidFill>
+                  <a:srgbClr val="171A18"/>
+                </a:solidFill>
+                <a:latin typeface="Plus Jakarta Sans"/>
+              </a:defRPr>
+            </a:pPr>
+            <a:r>
+              <a:t>Eco-Bricks</a:t>
+            </a:r>
+          </a:p>
+          <a:p>
+            <a:pPr>
+              <a:spcBef>
+                <a:spcPts val="600"/>
+              </a:spcBef>
+              <a:defRPr sz="1200">
+                <a:solidFill>
+                  <a:srgbClr val="526058"/>
+                </a:solidFill>
+                <a:latin typeface="Plus Jakarta Sans"/>
+              </a:defRPr>
+            </a:pPr>
+            <a:r>
+              <a:t>PET bottles tightly packed with clean plastic wrappers for modular garden walls and simple structures.</a:t>
+            </a:r>
+          </a:p>
+        </p:txBody>
+      </p:sp>
+      <p:sp>
+        <p:nvSpPr>
+          <p:cNvPr id="7" name="Rectangle 6"/>
+          <p:cNvSpPr/>
+          <p:nvPr/>
+        </p:nvSpPr>
+        <p:spPr>
+          <a:xfrm>
+            <a:off x="4480560" y="4389120"/>
+            <a:ext cx="3291840" cy="1965960"/>
+          </a:xfrm>
+          <a:prstGeom prst="rect">
+            <a:avLst/>
+          </a:prstGeom>
+          <a:solidFill>
+            <a:srgbClr val="F8FAF8"/>
+          </a:solidFill>
+          <a:ln w="12700">
+            <a:solidFill>
+              <a:srgbClr val="E2E8E0"/>
+            </a:solidFill>
+          </a:ln>
+        </p:spPr>
+        <p:style>
+          <a:lnRef idx="1">
+            <a:schemeClr val="accent1"/>
+          </a:lnRef>
+          <a:fillRef idx="3">
+            <a:schemeClr val="accent1"/>
+          </a:fillRef>
+          <a:effectRef idx="2">
+            <a:schemeClr val="accent1"/>
+          </a:effectRef>
+          <a:fontRef idx="minor">
+            <a:schemeClr val="lt1"/>
+          </a:fontRef>
+        </p:style>
+        <p:txBody>
+          <a:bodyPr rtlCol="0" anchor="ctr" wrap="square" lIns="182880" rIns="182880" tIns="164592"/>
+          <a:lstStyle/>
+          <a:p>
+            <a:pPr algn="ctr">
+              <a:defRPr sz="1000" b="1">
+                <a:solidFill>
+                  <a:srgbClr val="526058"/>
+                </a:solidFill>
+                <a:latin typeface="JetBrains Mono"/>
+              </a:defRPr>
+            </a:pPr>
+            <a:r>
+              <a:t>STUDENT-MADE</a:t>
+            </a:r>
+          </a:p>
+          <a:p>
+            <a:pPr>
+              <a:spcBef>
+                <a:spcPts val="400"/>
+              </a:spcBef>
+              <a:defRPr sz="1700" b="1">
+                <a:solidFill>
+                  <a:srgbClr val="171A18"/>
+                </a:solidFill>
+                <a:latin typeface="Plus Jakarta Sans"/>
+              </a:defRPr>
+            </a:pPr>
+            <a:r>
+              <a:t>Bottle Planters</a:t>
+            </a:r>
+          </a:p>
+          <a:p>
+            <a:pPr>
+              <a:spcBef>
+                <a:spcPts val="600"/>
+              </a:spcBef>
+              <a:defRPr sz="1200">
+                <a:solidFill>
+                  <a:srgbClr val="526058"/>
+                </a:solidFill>
+                <a:latin typeface="Plus Jakarta Sans"/>
+              </a:defRPr>
+            </a:pPr>
+            <a:r>
+              <a:t>Upcycled beverage containers for school corridor nursery and vertical greenery installations.</a:t>
+            </a:r>
+          </a:p>
+        </p:txBody>
+      </p:sp>
+      <p:sp>
+        <p:nvSpPr>
+          <p:cNvPr id="8" name="Rectangle 7"/>
+          <p:cNvSpPr/>
+          <p:nvPr/>
+        </p:nvSpPr>
+        <p:spPr>
+          <a:xfrm>
+            <a:off x="8138160" y="4389120"/>
+            <a:ext cx="3291840" cy="1965960"/>
+          </a:xfrm>
+          <a:prstGeom prst="rect">
+            <a:avLst/>
+          </a:prstGeom>
+          <a:solidFill>
+            <a:srgbClr val="F0F6F2"/>
+          </a:solidFill>
+          <a:ln w="19050">
+            <a:solidFill>
+              <a:srgbClr val="1F6B4F"/>
+            </a:solidFill>
+          </a:ln>
+        </p:spPr>
+        <p:style>
+          <a:lnRef idx="1">
+            <a:schemeClr val="accent1"/>
+          </a:lnRef>
+          <a:fillRef idx="3">
+            <a:schemeClr val="accent1"/>
+          </a:fillRef>
+          <a:effectRef idx="2">
+            <a:schemeClr val="accent1"/>
+          </a:effectRef>
+          <a:fontRef idx="minor">
+            <a:schemeClr val="lt1"/>
+          </a:fontRef>
+        </p:style>
+        <p:txBody>
+          <a:bodyPr rtlCol="0" anchor="ctr" wrap="square" lIns="182880" rIns="182880" tIns="164592"/>
+          <a:lstStyle/>
+          <a:p>
+            <a:pPr algn="ctr">
+              <a:defRPr sz="1000" b="1">
                 <a:solidFill>
                   <a:srgbClr val="1F6B4F"/>
                 </a:solidFill>
-                <a:latin typeface="Plus Jakarta Sans"/>
-              </a:defRPr>
-            </a:pPr>
-            <a:r>
-              <a:t>[MEME: "bro think he recyclable"]</a:t>
-            </a:r>
-          </a:p>
-          <a:p>
-            <a:pPr algn="ctr">
+                <a:latin typeface="JetBrains Mono"/>
+              </a:defRPr>
+            </a:pPr>
+            <a:r>
+              <a:t>NGO PARTNER</a:t>
+            </a:r>
+          </a:p>
+          <a:p>
+            <a:pPr>
               <a:spcBef>
-                <a:spcPts val="1200"/>
+                <a:spcPts val="400"/>
               </a:spcBef>
-              <a:defRPr sz="1300">
+              <a:defRPr sz="1700" b="1">
+                <a:solidFill>
+                  <a:srgbClr val="171A18"/>
+                </a:solidFill>
+                <a:latin typeface="Plus Jakarta Sans"/>
+              </a:defRPr>
+            </a:pPr>
+            <a:r>
+              <a:t>MLP Sheets</a:t>
+            </a:r>
+          </a:p>
+          <a:p>
+            <a:pPr>
+              <a:spcBef>
+                <a:spcPts val="600"/>
+              </a:spcBef>
+              <a:defRPr sz="1200">
                 <a:solidFill>
                   <a:srgbClr val="526058"/>
                 </a:solidFill>
@@ -5758,12 +6035,7 @@
               </a:defRPr>
             </a:pPr>
             <a:r>
-              <a:t>(Snack packaging trying to enter the recycling bin)</a:t>
-            </a:r>
-            <a:br/>
-            <a:br/>
-            <a:r>
-              <a:t>Drop your meme image here or delete this box</a:t>
+              <a:t>Heavy-duty structural boards heat-pressed from snack packaging using industrial hydraulic machinery.</a:t>
             </a:r>
           </a:p>
         </p:txBody>
@@ -6110,7 +6382,7 @@
         <p:spPr>
           <a:xfrm>
             <a:off x="6217920" y="2560320"/>
-            <a:ext cx="5120640" cy="2465616"/>
+            <a:ext cx="5120640" cy="2410968"/>
           </a:xfrm>
           <a:prstGeom prst="rect">
             <a:avLst/>

</xml_diff>

<commit_message>
update script and slides to reflect real bulk wrapper exchange and honest website catalog
</commit_message>
<xml_diff>
--- a/docs/presentation/ecoloop-presentation.pptx
+++ b/docs/presentation/ecoloop-presentation.pptx
@@ -6003,7 +6003,7 @@
               </a:defRPr>
             </a:pPr>
             <a:r>
-              <a:t>NGO PARTNER</a:t>
+              <a:t>BULK EXCHANGE</a:t>
             </a:r>
           </a:p>
           <a:p>
@@ -6035,7 +6035,7 @@
               </a:defRPr>
             </a:pPr>
             <a:r>
-              <a:t>Heavy-duty structural boards heat-pressed from snack packaging using industrial hydraulic machinery.</a:t>
+              <a:t>Heavy-duty structural boards heat-pressed by an external NGO from bulk wrapper batches.</a:t>
             </a:r>
           </a:p>
         </p:txBody>
@@ -6149,7 +6149,7 @@
               </a:defRPr>
             </a:pPr>
             <a:r>
-              <a:t>Started as scattered classroom craft projects. Turned into a unified circular brand with external partnerships and custom software.</a:t>
+              <a:t>Started as scattered classroom craft projects. Turned into a unified circular brand with bulk material exchange and custom software.</a:t>
             </a:r>
           </a:p>
         </p:txBody>
@@ -6219,7 +6219,7 @@
               </a:defRPr>
             </a:pPr>
             <a:r>
-              <a:t>Transforming school crafts into verifiable, specification-backed utility products.</a:t>
+              <a:t>Transforming scattered school crafts into a unified, public circular initiative.</a:t>
             </a:r>
           </a:p>
         </p:txBody>
@@ -6280,7 +6280,7 @@
                 </a:solidFill>
                 <a:latin typeface="Plus Jakarta Sans"/>
               </a:rPr>
-              <a:t>Engineering Credibility:
+              <a:t>Unified Public Presence:
 </a:t>
             </a:r>
             <a:r>
@@ -6290,7 +6290,7 @@
                 </a:solidFill>
                 <a:latin typeface="Plus Jakarta Sans"/>
               </a:rPr>
-              <a:t>   Publishing actual dimensions, material density, thermal ratings, and production lead times so buyers take recycled goods seriously.</a:t>
+              <a:t>   Showcasing all circular materials and workflows in one public place so it operates as a serious initiative, not scattered classroom crafts.</a:t>
             </a:r>
           </a:p>
           <a:p>
@@ -6325,7 +6325,7 @@
                 </a:solidFill>
                 <a:latin typeface="Plus Jakarta Sans"/>
               </a:rPr>
-              <a:t>   Giving institutions and partners a friction-free way to query available stock and request physical samples.</a:t>
+              <a:t>   Giving outside people and institutions a friction-free way to contact us and request physical samples.</a:t>
             </a:r>
           </a:p>
           <a:p>

</xml_diff>